<commit_message>
Refresh Work 3 evidence run and synchronize artifacts
</commit_message>
<xml_diff>
--- a/slides/Work3_Padding_Oracle_Presentation.pptx
+++ b/slides/Work3_Padding_Oracle_Presentation.pptx
@@ -2,24 +2,24 @@
 <file path=ppt/presentation.xml><?xml version="1.0" encoding="utf-8"?>
 <p:presentation xmlns:p="http://schemas.openxmlformats.org/presentationml/2006/main">
   <p:sldMasterIdLst>
-    <p:sldMasterId xmlns:r="http://schemas.openxmlformats.org/officeDocument/2006/relationships" id="2147483648" r:id="Rdb9e4bfc8c7f4fbf"/>
+    <p:sldMasterId xmlns:r="http://schemas.openxmlformats.org/officeDocument/2006/relationships" id="2147483648" r:id="R81da6d1320004340"/>
   </p:sldMasterIdLst>
   <p:notesMasterIdLst>
-    <p:notesMasterId xmlns:r="http://schemas.openxmlformats.org/officeDocument/2006/relationships" r:id="Re80ba0f03ecd4882"/>
+    <p:notesMasterId xmlns:r="http://schemas.openxmlformats.org/officeDocument/2006/relationships" r:id="R7c3be4eb30cf4b1e"/>
   </p:notesMasterIdLst>
   <p:sldIdLst>
-    <p:sldId xmlns:r="http://schemas.openxmlformats.org/officeDocument/2006/relationships" id="256" r:id="Re2e0175fe2df4f4f"/>
-    <p:sldId xmlns:r="http://schemas.openxmlformats.org/officeDocument/2006/relationships" id="257" r:id="R894a840d3bf14b4b"/>
-    <p:sldId xmlns:r="http://schemas.openxmlformats.org/officeDocument/2006/relationships" id="258" r:id="R9f28792a2c49410d"/>
-    <p:sldId xmlns:r="http://schemas.openxmlformats.org/officeDocument/2006/relationships" id="259" r:id="R914e260548b34d48"/>
-    <p:sldId xmlns:r="http://schemas.openxmlformats.org/officeDocument/2006/relationships" id="260" r:id="R94004dfe80f34133"/>
-    <p:sldId xmlns:r="http://schemas.openxmlformats.org/officeDocument/2006/relationships" id="261" r:id="R3abe1795b75c4e83"/>
-    <p:sldId xmlns:r="http://schemas.openxmlformats.org/officeDocument/2006/relationships" id="262" r:id="Ra40fd2b403f14a0e"/>
-    <p:sldId xmlns:r="http://schemas.openxmlformats.org/officeDocument/2006/relationships" id="263" r:id="Rb80d286d4aed4e65"/>
-    <p:sldId xmlns:r="http://schemas.openxmlformats.org/officeDocument/2006/relationships" id="264" r:id="Rbdc88c1407c14ab9"/>
-    <p:sldId xmlns:r="http://schemas.openxmlformats.org/officeDocument/2006/relationships" id="265" r:id="R903a097cfb424b07"/>
-    <p:sldId xmlns:r="http://schemas.openxmlformats.org/officeDocument/2006/relationships" id="266" r:id="R29977addcb6d4102"/>
-    <p:sldId xmlns:r="http://schemas.openxmlformats.org/officeDocument/2006/relationships" id="267" r:id="Re97dbd583a21430b"/>
+    <p:sldId xmlns:r="http://schemas.openxmlformats.org/officeDocument/2006/relationships" id="256" r:id="R1d445ea276f54a23"/>
+    <p:sldId xmlns:r="http://schemas.openxmlformats.org/officeDocument/2006/relationships" id="257" r:id="Re336ae6cb5c94262"/>
+    <p:sldId xmlns:r="http://schemas.openxmlformats.org/officeDocument/2006/relationships" id="258" r:id="Rd34601dbad2c49b9"/>
+    <p:sldId xmlns:r="http://schemas.openxmlformats.org/officeDocument/2006/relationships" id="259" r:id="R205110db3fd44c57"/>
+    <p:sldId xmlns:r="http://schemas.openxmlformats.org/officeDocument/2006/relationships" id="260" r:id="R680783e98885402c"/>
+    <p:sldId xmlns:r="http://schemas.openxmlformats.org/officeDocument/2006/relationships" id="261" r:id="Rdf1c0beee1bb422a"/>
+    <p:sldId xmlns:r="http://schemas.openxmlformats.org/officeDocument/2006/relationships" id="262" r:id="R5a87279854424205"/>
+    <p:sldId xmlns:r="http://schemas.openxmlformats.org/officeDocument/2006/relationships" id="263" r:id="R0ea98c71ccdd41c0"/>
+    <p:sldId xmlns:r="http://schemas.openxmlformats.org/officeDocument/2006/relationships" id="264" r:id="Rbc84baf2529c48a6"/>
+    <p:sldId xmlns:r="http://schemas.openxmlformats.org/officeDocument/2006/relationships" id="265" r:id="R7030aef9948e4341"/>
+    <p:sldId xmlns:r="http://schemas.openxmlformats.org/officeDocument/2006/relationships" id="266" r:id="Rc794929016534ed1"/>
+    <p:sldId xmlns:r="http://schemas.openxmlformats.org/officeDocument/2006/relationships" id="267" r:id="Rc12b645972224216"/>
   </p:sldIdLst>
   <p:sldSz cx="12192000" cy="6858000"/>
   <p:notesSz cx="6858000" cy="9144000"/>
@@ -943,7 +943,7 @@
           <a:lstStyle xmlns:a="http://schemas.openxmlformats.org/drawingml/2006/main"/>
           <a:p xmlns:a="http://schemas.openxmlformats.org/drawingml/2006/main">
             <a:r>
-              <a:t>For each position, try candidate bytes until the block ends in the desired padding. The successful guess reveals the intermediate byte, not the key. Set the next target to two bytes of 02, then three bytes of 03, and repeat. The demonstration used 4,713 requests for two blocks, consistent with the expected random search cost.</a:t>
+              <a:t>For each position, try candidate bytes until the block ends in the desired padding. The successful guess reveals the intermediate byte, not the key. Set the next target to two bytes of 02, then three bytes of 03, and repeat. The demonstration used 3,707 requests for two blocks, consistent with the expected random search cost.</a:t>
             </a:r>
           </a:p>
         </p:txBody>
@@ -1291,7 +1291,7 @@
   </p:cSld>
   <p:clrMap bg1="lt1" tx1="dk1" bg2="lt2" tx2="dk2" accent1="accent1" accent2="accent2" accent3="accent3" accent4="accent4" accent5="accent5" accent6="accent6" hlink="hlink" folHlink="folHlink"/>
   <p:sldLayoutIdLst>
-    <p:sldLayoutId xmlns:r="http://schemas.openxmlformats.org/officeDocument/2006/relationships" id="2147483649" r:id="R6663bc2470624922"/>
+    <p:sldLayoutId xmlns:r="http://schemas.openxmlformats.org/officeDocument/2006/relationships" id="2147483649" r:id="R4b993deee4f44028"/>
   </p:sldLayoutIdLst>
   <p:txStyles>
     <p:titleStyle>
@@ -1842,7 +1842,7 @@
           <p:cNvPr id="25" name="">
             <a:extLst xmlns:a="http://schemas.openxmlformats.org/drawingml/2006/main">
               <a:ext uri="{FF2B5EF4-FFF2-40B4-BE49-F238E27FC236}">
-                <a16:creationId xmlns:a16="http://schemas.microsoft.com/office/drawing/2014/main" id="{173DE828-5BCB-4937-A90F-25FB74937405}"/>
+                <a16:creationId xmlns:a16="http://schemas.microsoft.com/office/drawing/2014/main" id="{B6865847-8EAF-4522-B329-BAC475DB9C3C}"/>
               </a:ext>
             </a:extLst>
           </p:cNvPr>
@@ -1875,7 +1875,7 @@
           <p:cNvPr id="2" name="">
             <a:extLst xmlns:a="http://schemas.openxmlformats.org/drawingml/2006/main">
               <a:ext uri="{FF2B5EF4-FFF2-40B4-BE49-F238E27FC236}">
-                <a16:creationId xmlns:a16="http://schemas.microsoft.com/office/drawing/2014/main" id="{F9D5EABE-C7F5-4531-B89C-32084D6970EA}"/>
+                <a16:creationId xmlns:a16="http://schemas.microsoft.com/office/drawing/2014/main" id="{82363C7F-BA39-49B1-82EC-D7E57688C82D}"/>
               </a:ext>
             </a:extLst>
           </p:cNvPr>
@@ -1908,7 +1908,7 @@
           <p:cNvPr id="3" name="">
             <a:extLst xmlns:a="http://schemas.openxmlformats.org/drawingml/2006/main">
               <a:ext uri="{FF2B5EF4-FFF2-40B4-BE49-F238E27FC236}">
-                <a16:creationId xmlns:a16="http://schemas.microsoft.com/office/drawing/2014/main" id="{AA776058-C969-47A6-9920-CE8455511C07}"/>
+                <a16:creationId xmlns:a16="http://schemas.microsoft.com/office/drawing/2014/main" id="{2F02923C-8EC0-4A92-8934-DF7BB86505D9}"/>
               </a:ext>
             </a:extLst>
           </p:cNvPr>
@@ -1941,7 +1941,7 @@
           <p:cNvPr id="4" name="">
             <a:extLst xmlns:a="http://schemas.openxmlformats.org/drawingml/2006/main">
               <a:ext uri="{FF2B5EF4-FFF2-40B4-BE49-F238E27FC236}">
-                <a16:creationId xmlns:a16="http://schemas.microsoft.com/office/drawing/2014/main" id="{43EE7E4A-461D-48E9-94B2-F757E8EEB56C}"/>
+                <a16:creationId xmlns:a16="http://schemas.microsoft.com/office/drawing/2014/main" id="{12F5A05C-41A4-4BC4-B44C-1291DF08CE89}"/>
               </a:ext>
             </a:extLst>
           </p:cNvPr>
@@ -1974,7 +1974,7 @@
           <p:cNvPr id="5" name="">
             <a:extLst xmlns:a="http://schemas.openxmlformats.org/drawingml/2006/main">
               <a:ext uri="{FF2B5EF4-FFF2-40B4-BE49-F238E27FC236}">
-                <a16:creationId xmlns:a16="http://schemas.microsoft.com/office/drawing/2014/main" id="{02426C78-AD5D-492C-96CE-79430EEF0D39}"/>
+                <a16:creationId xmlns:a16="http://schemas.microsoft.com/office/drawing/2014/main" id="{00C64BE5-7F7E-468D-81BD-3D9859BE8A07}"/>
               </a:ext>
             </a:extLst>
           </p:cNvPr>
@@ -2007,7 +2007,7 @@
           <p:cNvPr id="6" name="">
             <a:extLst xmlns:a="http://schemas.openxmlformats.org/drawingml/2006/main">
               <a:ext uri="{FF2B5EF4-FFF2-40B4-BE49-F238E27FC236}">
-                <a16:creationId xmlns:a16="http://schemas.microsoft.com/office/drawing/2014/main" id="{08A3BEE9-4832-4B42-BCEB-818CD001B1E2}"/>
+                <a16:creationId xmlns:a16="http://schemas.microsoft.com/office/drawing/2014/main" id="{BDAFCB60-DCE0-4107-A991-AD308422E876}"/>
               </a:ext>
             </a:extLst>
           </p:cNvPr>
@@ -2040,7 +2040,7 @@
           <p:cNvPr id="7" name="">
             <a:extLst xmlns:a="http://schemas.openxmlformats.org/drawingml/2006/main">
               <a:ext uri="{FF2B5EF4-FFF2-40B4-BE49-F238E27FC236}">
-                <a16:creationId xmlns:a16="http://schemas.microsoft.com/office/drawing/2014/main" id="{E1D2F2EF-ED6B-4AAE-A594-A8E4887AF209}"/>
+                <a16:creationId xmlns:a16="http://schemas.microsoft.com/office/drawing/2014/main" id="{8330B495-A791-49E9-A373-A09CC6012BE6}"/>
               </a:ext>
             </a:extLst>
           </p:cNvPr>
@@ -2073,7 +2073,7 @@
           <p:cNvPr id="8" name="">
             <a:extLst xmlns:a="http://schemas.openxmlformats.org/drawingml/2006/main">
               <a:ext uri="{FF2B5EF4-FFF2-40B4-BE49-F238E27FC236}">
-                <a16:creationId xmlns:a16="http://schemas.microsoft.com/office/drawing/2014/main" id="{9BA07D39-FF34-4AB4-A2CC-47530D11B98A}"/>
+                <a16:creationId xmlns:a16="http://schemas.microsoft.com/office/drawing/2014/main" id="{D78A8782-363C-4953-97FE-02B0C0E4DBC6}"/>
               </a:ext>
             </a:extLst>
           </p:cNvPr>
@@ -2106,7 +2106,7 @@
           <p:cNvPr id="9" name="text">
             <a:extLst xmlns:a="http://schemas.openxmlformats.org/drawingml/2006/main">
               <a:ext uri="{FF2B5EF4-FFF2-40B4-BE49-F238E27FC236}">
-                <a16:creationId xmlns:a16="http://schemas.microsoft.com/office/drawing/2014/main" id="{443879CE-828E-4F2B-A120-6B22DE3CF33D}"/>
+                <a16:creationId xmlns:a16="http://schemas.microsoft.com/office/drawing/2014/main" id="{9EE8915D-731E-49D4-90D8-E0CB4214A209}"/>
               </a:ext>
             </a:extLst>
           </p:cNvPr>
@@ -2168,7 +2168,7 @@
           <p:cNvPr id="10" name="text">
             <a:extLst xmlns:a="http://schemas.openxmlformats.org/drawingml/2006/main">
               <a:ext uri="{FF2B5EF4-FFF2-40B4-BE49-F238E27FC236}">
-                <a16:creationId xmlns:a16="http://schemas.microsoft.com/office/drawing/2014/main" id="{3EFD83CC-ED17-4492-AF66-FBFEB8CA707B}"/>
+                <a16:creationId xmlns:a16="http://schemas.microsoft.com/office/drawing/2014/main" id="{BFF816C0-FD1B-4C28-ADF3-5AAC7F8D9F5A}"/>
               </a:ext>
             </a:extLst>
           </p:cNvPr>
@@ -2230,7 +2230,7 @@
           <p:cNvPr id="11" name="text">
             <a:extLst xmlns:a="http://schemas.openxmlformats.org/drawingml/2006/main">
               <a:ext uri="{FF2B5EF4-FFF2-40B4-BE49-F238E27FC236}">
-                <a16:creationId xmlns:a16="http://schemas.microsoft.com/office/drawing/2014/main" id="{70E1B4EA-C611-4A7D-95A5-B027662FBE63}"/>
+                <a16:creationId xmlns:a16="http://schemas.microsoft.com/office/drawing/2014/main" id="{B0EBCED2-3AC3-445E-8DA1-928BD448E917}"/>
               </a:ext>
             </a:extLst>
           </p:cNvPr>
@@ -2292,7 +2292,7 @@
           <p:cNvPr id="12" name="">
             <a:extLst xmlns:a="http://schemas.openxmlformats.org/drawingml/2006/main">
               <a:ext uri="{FF2B5EF4-FFF2-40B4-BE49-F238E27FC236}">
-                <a16:creationId xmlns:a16="http://schemas.microsoft.com/office/drawing/2014/main" id="{3B8346F3-732A-4664-B7EA-9B44AF1E3CC7}"/>
+                <a16:creationId xmlns:a16="http://schemas.microsoft.com/office/drawing/2014/main" id="{74695103-1E1F-4028-87C1-39D1E306D081}"/>
               </a:ext>
             </a:extLst>
           </p:cNvPr>
@@ -2325,7 +2325,7 @@
           <p:cNvPr id="13" name="">
             <a:extLst xmlns:a="http://schemas.openxmlformats.org/drawingml/2006/main">
               <a:ext uri="{FF2B5EF4-FFF2-40B4-BE49-F238E27FC236}">
-                <a16:creationId xmlns:a16="http://schemas.microsoft.com/office/drawing/2014/main" id="{2DB004B4-4BC2-45FD-80F2-1A90C56AAA35}"/>
+                <a16:creationId xmlns:a16="http://schemas.microsoft.com/office/drawing/2014/main" id="{BA49BD65-B7E4-4022-994E-D3CB0141040B}"/>
               </a:ext>
             </a:extLst>
           </p:cNvPr>
@@ -2387,7 +2387,7 @@
           <p:cNvPr id="14" name="">
             <a:extLst xmlns:a="http://schemas.openxmlformats.org/drawingml/2006/main">
               <a:ext uri="{FF2B5EF4-FFF2-40B4-BE49-F238E27FC236}">
-                <a16:creationId xmlns:a16="http://schemas.microsoft.com/office/drawing/2014/main" id="{144339AD-3C0B-43FD-8C19-9A4F81D76D04}"/>
+                <a16:creationId xmlns:a16="http://schemas.microsoft.com/office/drawing/2014/main" id="{C58BD572-6D2A-4DCA-92FA-1E5D5951C084}"/>
               </a:ext>
             </a:extLst>
           </p:cNvPr>
@@ -2449,7 +2449,7 @@
           <p:cNvPr id="15" name="">
             <a:extLst xmlns:a="http://schemas.openxmlformats.org/drawingml/2006/main">
               <a:ext uri="{FF2B5EF4-FFF2-40B4-BE49-F238E27FC236}">
-                <a16:creationId xmlns:a16="http://schemas.microsoft.com/office/drawing/2014/main" id="{8E7DC00C-29B6-4699-8823-16DCCC738ED4}"/>
+                <a16:creationId xmlns:a16="http://schemas.microsoft.com/office/drawing/2014/main" id="{9185AC7C-71C4-49A3-8F13-2F1CEDCDE823}"/>
               </a:ext>
             </a:extLst>
           </p:cNvPr>
@@ -2511,7 +2511,7 @@
           <p:cNvPr id="16" name="">
             <a:extLst xmlns:a="http://schemas.openxmlformats.org/drawingml/2006/main">
               <a:ext uri="{FF2B5EF4-FFF2-40B4-BE49-F238E27FC236}">
-                <a16:creationId xmlns:a16="http://schemas.microsoft.com/office/drawing/2014/main" id="{DDE2E3E1-4BAB-4897-AF01-C4DBD062EAF0}"/>
+                <a16:creationId xmlns:a16="http://schemas.microsoft.com/office/drawing/2014/main" id="{5294EDA6-7EF3-48F5-8502-C346FED58053}"/>
               </a:ext>
             </a:extLst>
           </p:cNvPr>
@@ -2573,7 +2573,7 @@
           <p:cNvPr id="17" name="">
             <a:extLst xmlns:a="http://schemas.openxmlformats.org/drawingml/2006/main">
               <a:ext uri="{FF2B5EF4-FFF2-40B4-BE49-F238E27FC236}">
-                <a16:creationId xmlns:a16="http://schemas.microsoft.com/office/drawing/2014/main" id="{D8436927-808C-4278-9D88-27CE70FCA234}"/>
+                <a16:creationId xmlns:a16="http://schemas.microsoft.com/office/drawing/2014/main" id="{1D304350-09D8-4BE8-879E-FF91A2DA6200}"/>
               </a:ext>
             </a:extLst>
           </p:cNvPr>
@@ -2635,7 +2635,7 @@
           <p:cNvPr id="18" name="">
             <a:extLst xmlns:a="http://schemas.openxmlformats.org/drawingml/2006/main">
               <a:ext uri="{FF2B5EF4-FFF2-40B4-BE49-F238E27FC236}">
-                <a16:creationId xmlns:a16="http://schemas.microsoft.com/office/drawing/2014/main" id="{D51A0D0B-E83E-4877-845F-5632DE19AA55}"/>
+                <a16:creationId xmlns:a16="http://schemas.microsoft.com/office/drawing/2014/main" id="{216194F5-B3D4-4F5F-BEA4-4F68347A975F}"/>
               </a:ext>
             </a:extLst>
           </p:cNvPr>
@@ -2697,7 +2697,7 @@
           <p:cNvPr id="19" name="">
             <a:extLst xmlns:a="http://schemas.openxmlformats.org/drawingml/2006/main">
               <a:ext uri="{FF2B5EF4-FFF2-40B4-BE49-F238E27FC236}">
-                <a16:creationId xmlns:a16="http://schemas.microsoft.com/office/drawing/2014/main" id="{ACE9CC95-6256-4DE1-B60A-E444E850D8C6}"/>
+                <a16:creationId xmlns:a16="http://schemas.microsoft.com/office/drawing/2014/main" id="{7235A540-947A-4082-926D-EEE0C3751EA0}"/>
               </a:ext>
             </a:extLst>
           </p:cNvPr>
@@ -2759,7 +2759,7 @@
           <p:cNvPr id="20" name="">
             <a:extLst xmlns:a="http://schemas.openxmlformats.org/drawingml/2006/main">
               <a:ext uri="{FF2B5EF4-FFF2-40B4-BE49-F238E27FC236}">
-                <a16:creationId xmlns:a16="http://schemas.microsoft.com/office/drawing/2014/main" id="{71DCF06D-56B1-4068-91C5-0ECFEFD8C45E}"/>
+                <a16:creationId xmlns:a16="http://schemas.microsoft.com/office/drawing/2014/main" id="{F2DD5CD2-6151-4D0C-BB8B-261FA519F1B8}"/>
               </a:ext>
             </a:extLst>
           </p:cNvPr>
@@ -2821,7 +2821,7 @@
           <p:cNvPr id="21" name="">
             <a:extLst xmlns:a="http://schemas.openxmlformats.org/drawingml/2006/main">
               <a:ext uri="{FF2B5EF4-FFF2-40B4-BE49-F238E27FC236}">
-                <a16:creationId xmlns:a16="http://schemas.microsoft.com/office/drawing/2014/main" id="{666CBD9F-C4F5-405D-AEB7-5F475F1B7D38}"/>
+                <a16:creationId xmlns:a16="http://schemas.microsoft.com/office/drawing/2014/main" id="{4288CAF7-563F-4A43-9138-489F7D2ABE5D}"/>
               </a:ext>
             </a:extLst>
           </p:cNvPr>
@@ -2883,7 +2883,7 @@
           <p:cNvPr id="22" name="text">
             <a:extLst xmlns:a="http://schemas.openxmlformats.org/drawingml/2006/main">
               <a:ext uri="{FF2B5EF4-FFF2-40B4-BE49-F238E27FC236}">
-                <a16:creationId xmlns:a16="http://schemas.microsoft.com/office/drawing/2014/main" id="{CDD5FF91-3CBF-432B-B3FE-A13711DCC95C}"/>
+                <a16:creationId xmlns:a16="http://schemas.microsoft.com/office/drawing/2014/main" id="{8FC0AFFC-BECF-44DA-ADD9-B4E67A9BF1F7}"/>
               </a:ext>
             </a:extLst>
           </p:cNvPr>
@@ -2945,7 +2945,7 @@
           <p:cNvPr id="23" name="text">
             <a:extLst xmlns:a="http://schemas.openxmlformats.org/drawingml/2006/main">
               <a:ext uri="{FF2B5EF4-FFF2-40B4-BE49-F238E27FC236}">
-                <a16:creationId xmlns:a16="http://schemas.microsoft.com/office/drawing/2014/main" id="{8B75E111-B59A-4839-A1A2-748F5794C1D0}"/>
+                <a16:creationId xmlns:a16="http://schemas.microsoft.com/office/drawing/2014/main" id="{94E3F316-A88A-42C2-9D7B-73FA5F72D464}"/>
               </a:ext>
             </a:extLst>
           </p:cNvPr>
@@ -3007,7 +3007,7 @@
           <p:cNvPr id="24" name="text">
             <a:extLst xmlns:a="http://schemas.openxmlformats.org/drawingml/2006/main">
               <a:ext uri="{FF2B5EF4-FFF2-40B4-BE49-F238E27FC236}">
-                <a16:creationId xmlns:a16="http://schemas.microsoft.com/office/drawing/2014/main" id="{AB9F0773-5E3B-40D1-BFA4-BF647D9BC777}"/>
+                <a16:creationId xmlns:a16="http://schemas.microsoft.com/office/drawing/2014/main" id="{B9D1EF03-190A-4DD6-93B2-E76B1F469C05}"/>
               </a:ext>
             </a:extLst>
           </p:cNvPr>
@@ -3067,7 +3067,7 @@
     </p:spTree>
     <p:extLst>
       <p:ext uri="{BB962C8B-B14F-4D97-AF65-F5344CB8AC3E}">
-        <p14:creationId xmlns:p14="http://schemas.microsoft.com/office/powerpoint/2010/main" val="1864630840"/>
+        <p14:creationId xmlns:p14="http://schemas.microsoft.com/office/powerpoint/2010/main" val="423772118"/>
       </p:ext>
     </p:extLst>
   </p:cSld>
@@ -3098,7 +3098,7 @@
           <p:cNvPr id="5" name="title">
             <a:extLst xmlns:a="http://schemas.openxmlformats.org/drawingml/2006/main">
               <a:ext uri="{FF2B5EF4-FFF2-40B4-BE49-F238E27FC236}">
-                <a16:creationId xmlns:a16="http://schemas.microsoft.com/office/drawing/2014/main" id="{417EFF50-1CE5-482B-A2AB-4899E937042B}"/>
+                <a16:creationId xmlns:a16="http://schemas.microsoft.com/office/drawing/2014/main" id="{9E12A9E0-E4CB-4699-B61A-E56367CBF3FD}"/>
               </a:ext>
             </a:extLst>
           </p:cNvPr>
@@ -3479,7 +3479,7 @@
           <p:cNvPr id="3" name="text">
             <a:extLst xmlns:a="http://schemas.openxmlformats.org/drawingml/2006/main">
               <a:ext uri="{FF2B5EF4-FFF2-40B4-BE49-F238E27FC236}">
-                <a16:creationId xmlns:a16="http://schemas.microsoft.com/office/drawing/2014/main" id="{A046123F-953F-456F-BAB3-B4D728F66BA1}"/>
+                <a16:creationId xmlns:a16="http://schemas.microsoft.com/office/drawing/2014/main" id="{B51DED0C-5A1D-465B-880D-8C5E65529D26}"/>
               </a:ext>
             </a:extLst>
           </p:cNvPr>
@@ -3541,7 +3541,7 @@
           <p:cNvPr id="4" name="slide-number">
             <a:extLst xmlns:a="http://schemas.openxmlformats.org/drawingml/2006/main">
               <a:ext uri="{FF2B5EF4-FFF2-40B4-BE49-F238E27FC236}">
-                <a16:creationId xmlns:a16="http://schemas.microsoft.com/office/drawing/2014/main" id="{3A1705E6-C234-4D00-A3CF-C2957E8D96E8}"/>
+                <a16:creationId xmlns:a16="http://schemas.microsoft.com/office/drawing/2014/main" id="{1EDE065D-03B1-48E0-A84F-C9F7695E39DA}"/>
               </a:ext>
             </a:extLst>
           </p:cNvPr>
@@ -3601,7 +3601,7 @@
     </p:spTree>
     <p:extLst>
       <p:ext uri="{BB962C8B-B14F-4D97-AF65-F5344CB8AC3E}">
-        <p14:creationId xmlns:p14="http://schemas.microsoft.com/office/powerpoint/2010/main" val="1645401149"/>
+        <p14:creationId xmlns:p14="http://schemas.microsoft.com/office/powerpoint/2010/main" val="1251476344"/>
       </p:ext>
     </p:extLst>
   </p:cSld>
@@ -3632,7 +3632,7 @@
           <p:cNvPr id="7" name="title">
             <a:extLst xmlns:a="http://schemas.openxmlformats.org/drawingml/2006/main">
               <a:ext uri="{FF2B5EF4-FFF2-40B4-BE49-F238E27FC236}">
-                <a16:creationId xmlns:a16="http://schemas.microsoft.com/office/drawing/2014/main" id="{04F8609A-CCFA-4C78-88E9-1E2974CDB2FA}"/>
+                <a16:creationId xmlns:a16="http://schemas.microsoft.com/office/drawing/2014/main" id="{5530C1B3-EDBF-4D72-980B-DBE26C4E9615}"/>
               </a:ext>
             </a:extLst>
           </p:cNvPr>
@@ -3694,7 +3694,7 @@
           <p:cNvPr id="2" name="text">
             <a:extLst xmlns:a="http://schemas.openxmlformats.org/drawingml/2006/main">
               <a:ext uri="{FF2B5EF4-FFF2-40B4-BE49-F238E27FC236}">
-                <a16:creationId xmlns:a16="http://schemas.microsoft.com/office/drawing/2014/main" id="{89AB79E9-64BF-4CF1-AE59-459C2706D4B6}"/>
+                <a16:creationId xmlns:a16="http://schemas.microsoft.com/office/drawing/2014/main" id="{40B8C580-08FE-4EC3-868A-DCAC3A1BCCFF}"/>
               </a:ext>
             </a:extLst>
           </p:cNvPr>
@@ -4149,7 +4149,7 @@
           <p:cNvPr id="4" name="">
             <a:extLst xmlns:a="http://schemas.openxmlformats.org/drawingml/2006/main">
               <a:ext uri="{FF2B5EF4-FFF2-40B4-BE49-F238E27FC236}">
-                <a16:creationId xmlns:a16="http://schemas.microsoft.com/office/drawing/2014/main" id="{2DA18BDC-EC52-4A89-9FFF-E7266AA83660}"/>
+                <a16:creationId xmlns:a16="http://schemas.microsoft.com/office/drawing/2014/main" id="{8CF51E5C-F76C-4893-BFAD-FA4EA182CC9E}"/>
               </a:ext>
             </a:extLst>
           </p:cNvPr>
@@ -4184,7 +4184,7 @@
           <p:cNvPr id="5" name="text">
             <a:extLst xmlns:a="http://schemas.openxmlformats.org/drawingml/2006/main">
               <a:ext uri="{FF2B5EF4-FFF2-40B4-BE49-F238E27FC236}">
-                <a16:creationId xmlns:a16="http://schemas.microsoft.com/office/drawing/2014/main" id="{462A1BD9-5616-4352-B404-DD5A1E210B42}"/>
+                <a16:creationId xmlns:a16="http://schemas.microsoft.com/office/drawing/2014/main" id="{F13CC757-416F-42C1-8A05-3AC2D90DCE36}"/>
               </a:ext>
             </a:extLst>
           </p:cNvPr>
@@ -4246,7 +4246,7 @@
           <p:cNvPr id="6" name="slide-number">
             <a:extLst xmlns:a="http://schemas.openxmlformats.org/drawingml/2006/main">
               <a:ext uri="{FF2B5EF4-FFF2-40B4-BE49-F238E27FC236}">
-                <a16:creationId xmlns:a16="http://schemas.microsoft.com/office/drawing/2014/main" id="{646FD4DB-9962-4EBF-8441-596235F8AFA5}"/>
+                <a16:creationId xmlns:a16="http://schemas.microsoft.com/office/drawing/2014/main" id="{EE08194C-F700-47FA-8996-B10348067538}"/>
               </a:ext>
             </a:extLst>
           </p:cNvPr>
@@ -4306,7 +4306,7 @@
     </p:spTree>
     <p:extLst>
       <p:ext uri="{BB962C8B-B14F-4D97-AF65-F5344CB8AC3E}">
-        <p14:creationId xmlns:p14="http://schemas.microsoft.com/office/powerpoint/2010/main" val="1333230032"/>
+        <p14:creationId xmlns:p14="http://schemas.microsoft.com/office/powerpoint/2010/main" val="143278112"/>
       </p:ext>
     </p:extLst>
   </p:cSld>
@@ -4337,7 +4337,7 @@
           <p:cNvPr id="14" name="title">
             <a:extLst xmlns:a="http://schemas.openxmlformats.org/drawingml/2006/main">
               <a:ext uri="{FF2B5EF4-FFF2-40B4-BE49-F238E27FC236}">
-                <a16:creationId xmlns:a16="http://schemas.microsoft.com/office/drawing/2014/main" id="{2A572109-B1AD-4DC3-9D79-5347068BD284}"/>
+                <a16:creationId xmlns:a16="http://schemas.microsoft.com/office/drawing/2014/main" id="{24D59408-E8E0-4E95-B959-A658D1DB94C7}"/>
               </a:ext>
             </a:extLst>
           </p:cNvPr>
@@ -4399,7 +4399,7 @@
           <p:cNvPr id="2" name="text">
             <a:extLst xmlns:a="http://schemas.openxmlformats.org/drawingml/2006/main">
               <a:ext uri="{FF2B5EF4-FFF2-40B4-BE49-F238E27FC236}">
-                <a16:creationId xmlns:a16="http://schemas.microsoft.com/office/drawing/2014/main" id="{631AE831-0289-40DB-93AC-42C7D115F0CA}"/>
+                <a16:creationId xmlns:a16="http://schemas.microsoft.com/office/drawing/2014/main" id="{ACB7C9EC-A581-4018-8443-448D4496711E}"/>
               </a:ext>
             </a:extLst>
           </p:cNvPr>
@@ -4461,7 +4461,7 @@
           <p:cNvPr id="3" name="text">
             <a:extLst xmlns:a="http://schemas.openxmlformats.org/drawingml/2006/main">
               <a:ext uri="{FF2B5EF4-FFF2-40B4-BE49-F238E27FC236}">
-                <a16:creationId xmlns:a16="http://schemas.microsoft.com/office/drawing/2014/main" id="{538FCD60-133E-4290-B9EA-56904BA1799C}"/>
+                <a16:creationId xmlns:a16="http://schemas.microsoft.com/office/drawing/2014/main" id="{2E108805-6ACB-4B96-8F1B-372F5F8D22D4}"/>
               </a:ext>
             </a:extLst>
           </p:cNvPr>
@@ -4523,7 +4523,7 @@
           <p:cNvPr id="4" name="text">
             <a:extLst xmlns:a="http://schemas.openxmlformats.org/drawingml/2006/main">
               <a:ext uri="{FF2B5EF4-FFF2-40B4-BE49-F238E27FC236}">
-                <a16:creationId xmlns:a16="http://schemas.microsoft.com/office/drawing/2014/main" id="{B04AF42C-EC4B-42EC-9472-D76037FC95D8}"/>
+                <a16:creationId xmlns:a16="http://schemas.microsoft.com/office/drawing/2014/main" id="{A6103D5F-C682-49B2-99F5-762D9F5D3434}"/>
               </a:ext>
             </a:extLst>
           </p:cNvPr>
@@ -4585,7 +4585,7 @@
           <p:cNvPr id="5" name="text">
             <a:extLst xmlns:a="http://schemas.openxmlformats.org/drawingml/2006/main">
               <a:ext uri="{FF2B5EF4-FFF2-40B4-BE49-F238E27FC236}">
-                <a16:creationId xmlns:a16="http://schemas.microsoft.com/office/drawing/2014/main" id="{692200EC-889D-46DC-BADC-B1340D38911B}"/>
+                <a16:creationId xmlns:a16="http://schemas.microsoft.com/office/drawing/2014/main" id="{A53F8F86-70A5-4663-93E8-C312563FB945}"/>
               </a:ext>
             </a:extLst>
           </p:cNvPr>
@@ -4647,7 +4647,7 @@
           <p:cNvPr id="6" name="text">
             <a:extLst xmlns:a="http://schemas.openxmlformats.org/drawingml/2006/main">
               <a:ext uri="{FF2B5EF4-FFF2-40B4-BE49-F238E27FC236}">
-                <a16:creationId xmlns:a16="http://schemas.microsoft.com/office/drawing/2014/main" id="{D249D945-C100-485C-98C1-49F0D6AE1B51}"/>
+                <a16:creationId xmlns:a16="http://schemas.microsoft.com/office/drawing/2014/main" id="{8FB327F2-8F69-435B-889A-672B763D0DDD}"/>
               </a:ext>
             </a:extLst>
           </p:cNvPr>
@@ -4709,7 +4709,7 @@
           <p:cNvPr id="7" name="text">
             <a:extLst xmlns:a="http://schemas.openxmlformats.org/drawingml/2006/main">
               <a:ext uri="{FF2B5EF4-FFF2-40B4-BE49-F238E27FC236}">
-                <a16:creationId xmlns:a16="http://schemas.microsoft.com/office/drawing/2014/main" id="{F8EB84E3-874B-4333-A8C1-A61277B4B7D4}"/>
+                <a16:creationId xmlns:a16="http://schemas.microsoft.com/office/drawing/2014/main" id="{F8908590-6C48-4917-87B0-7893E0C5A5E4}"/>
               </a:ext>
             </a:extLst>
           </p:cNvPr>
@@ -4771,7 +4771,7 @@
           <p:cNvPr id="8" name="text">
             <a:extLst xmlns:a="http://schemas.openxmlformats.org/drawingml/2006/main">
               <a:ext uri="{FF2B5EF4-FFF2-40B4-BE49-F238E27FC236}">
-                <a16:creationId xmlns:a16="http://schemas.microsoft.com/office/drawing/2014/main" id="{4FE57151-8E15-4F92-BCDB-C63C9370BDB9}"/>
+                <a16:creationId xmlns:a16="http://schemas.microsoft.com/office/drawing/2014/main" id="{CD744772-1482-47CC-8228-17CC377FC527}"/>
               </a:ext>
             </a:extLst>
           </p:cNvPr>
@@ -4833,7 +4833,7 @@
           <p:cNvPr id="9" name="">
             <a:extLst xmlns:a="http://schemas.openxmlformats.org/drawingml/2006/main">
               <a:ext uri="{FF2B5EF4-FFF2-40B4-BE49-F238E27FC236}">
-                <a16:creationId xmlns:a16="http://schemas.microsoft.com/office/drawing/2014/main" id="{EFDF6E76-89E0-463A-88F6-B07D4C0135FD}"/>
+                <a16:creationId xmlns:a16="http://schemas.microsoft.com/office/drawing/2014/main" id="{8739BD0E-3076-4C42-AEEE-9AA7C7FF2B60}"/>
               </a:ext>
             </a:extLst>
           </p:cNvPr>
@@ -4866,7 +4866,7 @@
           <p:cNvPr id="10" name="text">
             <a:extLst xmlns:a="http://schemas.openxmlformats.org/drawingml/2006/main">
               <a:ext uri="{FF2B5EF4-FFF2-40B4-BE49-F238E27FC236}">
-                <a16:creationId xmlns:a16="http://schemas.microsoft.com/office/drawing/2014/main" id="{6ECD10FC-B638-42A7-AEFB-7458018CF24C}"/>
+                <a16:creationId xmlns:a16="http://schemas.microsoft.com/office/drawing/2014/main" id="{2A0B23F7-CB03-4371-9679-7099441EDE4F}"/>
               </a:ext>
             </a:extLst>
           </p:cNvPr>
@@ -4928,7 +4928,7 @@
           <p:cNvPr id="11" name="text">
             <a:extLst xmlns:a="http://schemas.openxmlformats.org/drawingml/2006/main">
               <a:ext uri="{FF2B5EF4-FFF2-40B4-BE49-F238E27FC236}">
-                <a16:creationId xmlns:a16="http://schemas.microsoft.com/office/drawing/2014/main" id="{23B6E7C2-978A-471B-9B61-20AD4B3D0EBD}"/>
+                <a16:creationId xmlns:a16="http://schemas.microsoft.com/office/drawing/2014/main" id="{283904EB-75E9-479C-B3DD-C9C03514BB3F}"/>
               </a:ext>
             </a:extLst>
           </p:cNvPr>
@@ -4990,7 +4990,7 @@
           <p:cNvPr id="12" name="text">
             <a:extLst xmlns:a="http://schemas.openxmlformats.org/drawingml/2006/main">
               <a:ext uri="{FF2B5EF4-FFF2-40B4-BE49-F238E27FC236}">
-                <a16:creationId xmlns:a16="http://schemas.microsoft.com/office/drawing/2014/main" id="{F4C75546-9A9E-43B1-ACCF-559925FB0114}"/>
+                <a16:creationId xmlns:a16="http://schemas.microsoft.com/office/drawing/2014/main" id="{C771E591-FF1E-477F-B648-B84A4802FE48}"/>
               </a:ext>
             </a:extLst>
           </p:cNvPr>
@@ -5052,7 +5052,7 @@
           <p:cNvPr id="13" name="slide-number">
             <a:extLst xmlns:a="http://schemas.openxmlformats.org/drawingml/2006/main">
               <a:ext uri="{FF2B5EF4-FFF2-40B4-BE49-F238E27FC236}">
-                <a16:creationId xmlns:a16="http://schemas.microsoft.com/office/drawing/2014/main" id="{FECF975F-C53E-4879-9E4A-A26C2753D714}"/>
+                <a16:creationId xmlns:a16="http://schemas.microsoft.com/office/drawing/2014/main" id="{7B3EB6EE-EE0A-4733-B2BF-ADA367DDFF17}"/>
               </a:ext>
             </a:extLst>
           </p:cNvPr>
@@ -5112,7 +5112,7 @@
     </p:spTree>
     <p:extLst>
       <p:ext uri="{BB962C8B-B14F-4D97-AF65-F5344CB8AC3E}">
-        <p14:creationId xmlns:p14="http://schemas.microsoft.com/office/powerpoint/2010/main" val="751841283"/>
+        <p14:creationId xmlns:p14="http://schemas.microsoft.com/office/powerpoint/2010/main" val="1914195807"/>
       </p:ext>
     </p:extLst>
   </p:cSld>
@@ -5143,7 +5143,7 @@
           <p:cNvPr id="17" name="title">
             <a:extLst xmlns:a="http://schemas.openxmlformats.org/drawingml/2006/main">
               <a:ext uri="{FF2B5EF4-FFF2-40B4-BE49-F238E27FC236}">
-                <a16:creationId xmlns:a16="http://schemas.microsoft.com/office/drawing/2014/main" id="{50D52ADF-B9CF-48E2-9806-D653D0C81A4E}"/>
+                <a16:creationId xmlns:a16="http://schemas.microsoft.com/office/drawing/2014/main" id="{09712952-3F53-48F6-82E3-CE68508C0BB2}"/>
               </a:ext>
             </a:extLst>
           </p:cNvPr>
@@ -5205,7 +5205,7 @@
           <p:cNvPr id="2" name="text">
             <a:extLst xmlns:a="http://schemas.openxmlformats.org/drawingml/2006/main">
               <a:ext uri="{FF2B5EF4-FFF2-40B4-BE49-F238E27FC236}">
-                <a16:creationId xmlns:a16="http://schemas.microsoft.com/office/drawing/2014/main" id="{C1331F76-946C-4AF3-99B0-5494D6C2C8EE}"/>
+                <a16:creationId xmlns:a16="http://schemas.microsoft.com/office/drawing/2014/main" id="{2E6C4349-B928-48A2-BE73-698A8EBEAD7F}"/>
               </a:ext>
             </a:extLst>
           </p:cNvPr>
@@ -5267,7 +5267,7 @@
           <p:cNvPr id="3" name="">
             <a:extLst xmlns:a="http://schemas.openxmlformats.org/drawingml/2006/main">
               <a:ext uri="{FF2B5EF4-FFF2-40B4-BE49-F238E27FC236}">
-                <a16:creationId xmlns:a16="http://schemas.microsoft.com/office/drawing/2014/main" id="{3EDE4D43-D9D5-4BEA-B245-93418FFD4DDF}"/>
+                <a16:creationId xmlns:a16="http://schemas.microsoft.com/office/drawing/2014/main" id="{499B911C-5624-451D-A5BD-BF7E541AA4E7}"/>
               </a:ext>
             </a:extLst>
           </p:cNvPr>
@@ -5300,7 +5300,7 @@
           <p:cNvPr id="4" name="text">
             <a:extLst xmlns:a="http://schemas.openxmlformats.org/drawingml/2006/main">
               <a:ext uri="{FF2B5EF4-FFF2-40B4-BE49-F238E27FC236}">
-                <a16:creationId xmlns:a16="http://schemas.microsoft.com/office/drawing/2014/main" id="{79EE4B86-16C2-4A90-85C8-CF13EC6F9329}"/>
+                <a16:creationId xmlns:a16="http://schemas.microsoft.com/office/drawing/2014/main" id="{A106EAA8-1537-426B-BAF7-11CFF1A5CE18}"/>
               </a:ext>
             </a:extLst>
           </p:cNvPr>
@@ -5362,7 +5362,7 @@
           <p:cNvPr id="5" name="text">
             <a:extLst xmlns:a="http://schemas.openxmlformats.org/drawingml/2006/main">
               <a:ext uri="{FF2B5EF4-FFF2-40B4-BE49-F238E27FC236}">
-                <a16:creationId xmlns:a16="http://schemas.microsoft.com/office/drawing/2014/main" id="{73AE3C45-B820-44B1-8CE7-AFA9CC27941D}"/>
+                <a16:creationId xmlns:a16="http://schemas.microsoft.com/office/drawing/2014/main" id="{1CCC909D-0E0D-4ACA-89F8-853BDD885EC0}"/>
               </a:ext>
             </a:extLst>
           </p:cNvPr>
@@ -5424,7 +5424,7 @@
           <p:cNvPr id="6" name="">
             <a:extLst xmlns:a="http://schemas.openxmlformats.org/drawingml/2006/main">
               <a:ext uri="{FF2B5EF4-FFF2-40B4-BE49-F238E27FC236}">
-                <a16:creationId xmlns:a16="http://schemas.microsoft.com/office/drawing/2014/main" id="{628D1C78-CB6F-4800-8694-23A809F59741}"/>
+                <a16:creationId xmlns:a16="http://schemas.microsoft.com/office/drawing/2014/main" id="{5449F3DB-0D84-4BFA-93D9-9B72F896FC09}"/>
               </a:ext>
             </a:extLst>
           </p:cNvPr>
@@ -5457,7 +5457,7 @@
           <p:cNvPr id="7" name="">
             <a:extLst xmlns:a="http://schemas.openxmlformats.org/drawingml/2006/main">
               <a:ext uri="{FF2B5EF4-FFF2-40B4-BE49-F238E27FC236}">
-                <a16:creationId xmlns:a16="http://schemas.microsoft.com/office/drawing/2014/main" id="{B3B311FC-0F3B-4A5A-B924-0DD0CEA82D36}"/>
+                <a16:creationId xmlns:a16="http://schemas.microsoft.com/office/drawing/2014/main" id="{1A06189E-63EE-48E1-9DDB-CB55C2B7A7E8}"/>
               </a:ext>
             </a:extLst>
           </p:cNvPr>
@@ -5490,7 +5490,7 @@
           <p:cNvPr id="8" name="text">
             <a:extLst xmlns:a="http://schemas.openxmlformats.org/drawingml/2006/main">
               <a:ext uri="{FF2B5EF4-FFF2-40B4-BE49-F238E27FC236}">
-                <a16:creationId xmlns:a16="http://schemas.microsoft.com/office/drawing/2014/main" id="{E2BEF1B1-D033-4C6B-9F73-62D27A356ADA}"/>
+                <a16:creationId xmlns:a16="http://schemas.microsoft.com/office/drawing/2014/main" id="{CAAAB4E1-3CA4-423B-A31B-212E9327E166}"/>
               </a:ext>
             </a:extLst>
           </p:cNvPr>
@@ -5552,7 +5552,7 @@
           <p:cNvPr id="9" name="text">
             <a:extLst xmlns:a="http://schemas.openxmlformats.org/drawingml/2006/main">
               <a:ext uri="{FF2B5EF4-FFF2-40B4-BE49-F238E27FC236}">
-                <a16:creationId xmlns:a16="http://schemas.microsoft.com/office/drawing/2014/main" id="{0A91832C-4B70-4585-8148-20137B307C66}"/>
+                <a16:creationId xmlns:a16="http://schemas.microsoft.com/office/drawing/2014/main" id="{973C3055-F77A-43E9-BF71-EF98D70E4809}"/>
               </a:ext>
             </a:extLst>
           </p:cNvPr>
@@ -5614,7 +5614,7 @@
           <p:cNvPr id="10" name="">
             <a:extLst xmlns:a="http://schemas.openxmlformats.org/drawingml/2006/main">
               <a:ext uri="{FF2B5EF4-FFF2-40B4-BE49-F238E27FC236}">
-                <a16:creationId xmlns:a16="http://schemas.microsoft.com/office/drawing/2014/main" id="{9C036C5B-ECD4-4DD7-8C41-8B506ABEC77F}"/>
+                <a16:creationId xmlns:a16="http://schemas.microsoft.com/office/drawing/2014/main" id="{663218FE-4E6C-42FD-94F1-EEF45DAE3175}"/>
               </a:ext>
             </a:extLst>
           </p:cNvPr>
@@ -5647,7 +5647,7 @@
           <p:cNvPr id="11" name="">
             <a:extLst xmlns:a="http://schemas.openxmlformats.org/drawingml/2006/main">
               <a:ext uri="{FF2B5EF4-FFF2-40B4-BE49-F238E27FC236}">
-                <a16:creationId xmlns:a16="http://schemas.microsoft.com/office/drawing/2014/main" id="{8C6FC048-5349-4AAF-BD86-C60ECE8A2B86}"/>
+                <a16:creationId xmlns:a16="http://schemas.microsoft.com/office/drawing/2014/main" id="{CCA056EC-F7F6-4FEA-8F50-B565DBF53551}"/>
               </a:ext>
             </a:extLst>
           </p:cNvPr>
@@ -5680,7 +5680,7 @@
           <p:cNvPr id="12" name="text">
             <a:extLst xmlns:a="http://schemas.openxmlformats.org/drawingml/2006/main">
               <a:ext uri="{FF2B5EF4-FFF2-40B4-BE49-F238E27FC236}">
-                <a16:creationId xmlns:a16="http://schemas.microsoft.com/office/drawing/2014/main" id="{7CBABF67-EEA0-4F24-80C4-9EE1D022AE0F}"/>
+                <a16:creationId xmlns:a16="http://schemas.microsoft.com/office/drawing/2014/main" id="{E7E3BE8A-C224-46DE-8071-6F3EA96A295A}"/>
               </a:ext>
             </a:extLst>
           </p:cNvPr>
@@ -5742,7 +5742,7 @@
           <p:cNvPr id="13" name="text">
             <a:extLst xmlns:a="http://schemas.openxmlformats.org/drawingml/2006/main">
               <a:ext uri="{FF2B5EF4-FFF2-40B4-BE49-F238E27FC236}">
-                <a16:creationId xmlns:a16="http://schemas.microsoft.com/office/drawing/2014/main" id="{F7B42DAF-DB29-47CD-A8FF-3889E5F8B705}"/>
+                <a16:creationId xmlns:a16="http://schemas.microsoft.com/office/drawing/2014/main" id="{8AE79A11-186F-4895-BC35-3293A87576E2}"/>
               </a:ext>
             </a:extLst>
           </p:cNvPr>
@@ -5804,7 +5804,7 @@
           <p:cNvPr id="14" name="">
             <a:extLst xmlns:a="http://schemas.openxmlformats.org/drawingml/2006/main">
               <a:ext uri="{FF2B5EF4-FFF2-40B4-BE49-F238E27FC236}">
-                <a16:creationId xmlns:a16="http://schemas.microsoft.com/office/drawing/2014/main" id="{A6B86F0E-47C1-4CC1-B629-2E2A21CD7524}"/>
+                <a16:creationId xmlns:a16="http://schemas.microsoft.com/office/drawing/2014/main" id="{9DC68071-7810-4485-A29C-EF8EF4E04CF3}"/>
               </a:ext>
             </a:extLst>
           </p:cNvPr>
@@ -5837,7 +5837,7 @@
           <p:cNvPr id="15" name="text">
             <a:extLst xmlns:a="http://schemas.openxmlformats.org/drawingml/2006/main">
               <a:ext uri="{FF2B5EF4-FFF2-40B4-BE49-F238E27FC236}">
-                <a16:creationId xmlns:a16="http://schemas.microsoft.com/office/drawing/2014/main" id="{5FBE6986-940F-41B5-A2AF-E0C9F2A3CD62}"/>
+                <a16:creationId xmlns:a16="http://schemas.microsoft.com/office/drawing/2014/main" id="{0BE49147-54AF-4D79-AB4B-125EAD87DFFC}"/>
               </a:ext>
             </a:extLst>
           </p:cNvPr>
@@ -5899,7 +5899,7 @@
           <p:cNvPr id="16" name="slide-number">
             <a:extLst xmlns:a="http://schemas.openxmlformats.org/drawingml/2006/main">
               <a:ext uri="{FF2B5EF4-FFF2-40B4-BE49-F238E27FC236}">
-                <a16:creationId xmlns:a16="http://schemas.microsoft.com/office/drawing/2014/main" id="{05D9C308-9491-4135-AF85-66F7FEB3A300}"/>
+                <a16:creationId xmlns:a16="http://schemas.microsoft.com/office/drawing/2014/main" id="{AF82E5F3-70EA-4526-81DA-F98052C72265}"/>
               </a:ext>
             </a:extLst>
           </p:cNvPr>
@@ -5959,7 +5959,7 @@
     </p:spTree>
     <p:extLst>
       <p:ext uri="{BB962C8B-B14F-4D97-AF65-F5344CB8AC3E}">
-        <p14:creationId xmlns:p14="http://schemas.microsoft.com/office/powerpoint/2010/main" val="1855535924"/>
+        <p14:creationId xmlns:p14="http://schemas.microsoft.com/office/powerpoint/2010/main" val="706691248"/>
       </p:ext>
     </p:extLst>
   </p:cSld>
@@ -5990,7 +5990,7 @@
           <p:cNvPr id="5" name="title">
             <a:extLst xmlns:a="http://schemas.openxmlformats.org/drawingml/2006/main">
               <a:ext uri="{FF2B5EF4-FFF2-40B4-BE49-F238E27FC236}">
-                <a16:creationId xmlns:a16="http://schemas.microsoft.com/office/drawing/2014/main" id="{CE57DFE7-B59E-4FED-9BBC-E51A6892FE23}"/>
+                <a16:creationId xmlns:a16="http://schemas.microsoft.com/office/drawing/2014/main" id="{2BB89D1C-D6D6-4151-9568-CB113156216C}"/>
               </a:ext>
             </a:extLst>
           </p:cNvPr>
@@ -6056,7 +6056,7 @@
           <p:nvPr/>
         </p:nvPicPr>
         <p:blipFill>
-          <a:blip xmlns:r="http://schemas.openxmlformats.org/officeDocument/2006/relationships" xmlns:a="http://schemas.openxmlformats.org/drawingml/2006/main" r:embed="Rd51b700185714e1b"/>
+          <a:blip xmlns:r="http://schemas.openxmlformats.org/officeDocument/2006/relationships" xmlns:a="http://schemas.openxmlformats.org/drawingml/2006/main" r:embed="R1083bc1c1437444c"/>
           <a:stretch xmlns:a="http://schemas.openxmlformats.org/drawingml/2006/main"/>
         </p:blipFill>
         <p:spPr>
@@ -6074,7 +6074,7 @@
           <p:cNvPr id="3" name="text">
             <a:extLst xmlns:a="http://schemas.openxmlformats.org/drawingml/2006/main">
               <a:ext uri="{FF2B5EF4-FFF2-40B4-BE49-F238E27FC236}">
-                <a16:creationId xmlns:a16="http://schemas.microsoft.com/office/drawing/2014/main" id="{E40C59A5-788B-4157-8381-150924401A9E}"/>
+                <a16:creationId xmlns:a16="http://schemas.microsoft.com/office/drawing/2014/main" id="{6A4A3A9A-2E51-4B58-8698-262D7C8B4035}"/>
               </a:ext>
             </a:extLst>
           </p:cNvPr>
@@ -6136,7 +6136,7 @@
           <p:cNvPr id="4" name="slide-number">
             <a:extLst xmlns:a="http://schemas.openxmlformats.org/drawingml/2006/main">
               <a:ext uri="{FF2B5EF4-FFF2-40B4-BE49-F238E27FC236}">
-                <a16:creationId xmlns:a16="http://schemas.microsoft.com/office/drawing/2014/main" id="{2722B7B6-7AA0-4B01-9967-22DAD904E4D3}"/>
+                <a16:creationId xmlns:a16="http://schemas.microsoft.com/office/drawing/2014/main" id="{9A375849-2AEB-4B2B-8AEF-7EAAF862570E}"/>
               </a:ext>
             </a:extLst>
           </p:cNvPr>
@@ -6196,7 +6196,7 @@
     </p:spTree>
     <p:extLst>
       <p:ext uri="{BB962C8B-B14F-4D97-AF65-F5344CB8AC3E}">
-        <p14:creationId xmlns:p14="http://schemas.microsoft.com/office/powerpoint/2010/main" val="1382480551"/>
+        <p14:creationId xmlns:p14="http://schemas.microsoft.com/office/powerpoint/2010/main" val="1259463920"/>
       </p:ext>
     </p:extLst>
   </p:cSld>
@@ -6227,7 +6227,7 @@
           <p:cNvPr id="19" name="title">
             <a:extLst xmlns:a="http://schemas.openxmlformats.org/drawingml/2006/main">
               <a:ext uri="{FF2B5EF4-FFF2-40B4-BE49-F238E27FC236}">
-                <a16:creationId xmlns:a16="http://schemas.microsoft.com/office/drawing/2014/main" id="{4CBED105-0B57-47EA-9710-11608A7A25E7}"/>
+                <a16:creationId xmlns:a16="http://schemas.microsoft.com/office/drawing/2014/main" id="{88FF349D-26CF-4C7B-9185-53F8169E5BB4}"/>
               </a:ext>
             </a:extLst>
           </p:cNvPr>
@@ -6289,7 +6289,7 @@
           <p:cNvPr id="2" name="text">
             <a:extLst xmlns:a="http://schemas.openxmlformats.org/drawingml/2006/main">
               <a:ext uri="{FF2B5EF4-FFF2-40B4-BE49-F238E27FC236}">
-                <a16:creationId xmlns:a16="http://schemas.microsoft.com/office/drawing/2014/main" id="{611DE2E4-E57B-4D44-A594-8E19902F056E}"/>
+                <a16:creationId xmlns:a16="http://schemas.microsoft.com/office/drawing/2014/main" id="{44F1E309-DB23-486B-AB15-56AD0A5995AC}"/>
               </a:ext>
             </a:extLst>
           </p:cNvPr>
@@ -6351,7 +6351,7 @@
           <p:cNvPr id="3" name="">
             <a:extLst xmlns:a="http://schemas.openxmlformats.org/drawingml/2006/main">
               <a:ext uri="{FF2B5EF4-FFF2-40B4-BE49-F238E27FC236}">
-                <a16:creationId xmlns:a16="http://schemas.microsoft.com/office/drawing/2014/main" id="{A508297C-53FB-4C6D-A90B-8348BE53159F}"/>
+                <a16:creationId xmlns:a16="http://schemas.microsoft.com/office/drawing/2014/main" id="{253421D8-7F1D-4750-8667-5C49444B4CEF}"/>
               </a:ext>
             </a:extLst>
           </p:cNvPr>
@@ -6386,7 +6386,7 @@
           <p:cNvPr id="4" name="">
             <a:extLst xmlns:a="http://schemas.openxmlformats.org/drawingml/2006/main">
               <a:ext uri="{FF2B5EF4-FFF2-40B4-BE49-F238E27FC236}">
-                <a16:creationId xmlns:a16="http://schemas.microsoft.com/office/drawing/2014/main" id="{A2EE1E99-78FF-47A7-B62F-01CA1F5AEC0D}"/>
+                <a16:creationId xmlns:a16="http://schemas.microsoft.com/office/drawing/2014/main" id="{9FFB2478-4D37-4CB4-83A8-1E7EE8CA3F91}"/>
               </a:ext>
             </a:extLst>
           </p:cNvPr>
@@ -6421,7 +6421,7 @@
           <p:cNvPr id="5" name="">
             <a:extLst xmlns:a="http://schemas.openxmlformats.org/drawingml/2006/main">
               <a:ext uri="{FF2B5EF4-FFF2-40B4-BE49-F238E27FC236}">
-                <a16:creationId xmlns:a16="http://schemas.microsoft.com/office/drawing/2014/main" id="{094A20C6-1737-4B45-AC5E-A00EBB8F40A5}"/>
+                <a16:creationId xmlns:a16="http://schemas.microsoft.com/office/drawing/2014/main" id="{42F468AC-FF9E-4026-88B4-E5F48A587C03}"/>
               </a:ext>
             </a:extLst>
           </p:cNvPr>
@@ -6456,7 +6456,7 @@
           <p:cNvPr id="6" name="text">
             <a:extLst xmlns:a="http://schemas.openxmlformats.org/drawingml/2006/main">
               <a:ext uri="{FF2B5EF4-FFF2-40B4-BE49-F238E27FC236}">
-                <a16:creationId xmlns:a16="http://schemas.microsoft.com/office/drawing/2014/main" id="{08EC9494-82EB-4AAB-AA3A-375E001BB657}"/>
+                <a16:creationId xmlns:a16="http://schemas.microsoft.com/office/drawing/2014/main" id="{5405C53D-D778-4A3D-B2FE-F79C271DF240}"/>
               </a:ext>
             </a:extLst>
           </p:cNvPr>
@@ -6518,7 +6518,7 @@
           <p:cNvPr id="7" name="text">
             <a:extLst xmlns:a="http://schemas.openxmlformats.org/drawingml/2006/main">
               <a:ext uri="{FF2B5EF4-FFF2-40B4-BE49-F238E27FC236}">
-                <a16:creationId xmlns:a16="http://schemas.microsoft.com/office/drawing/2014/main" id="{B10C3A75-81AC-439F-87C1-FB1B3C0CC103}"/>
+                <a16:creationId xmlns:a16="http://schemas.microsoft.com/office/drawing/2014/main" id="{154BBAE0-FF44-4874-9AE2-75DE3CCD6188}"/>
               </a:ext>
             </a:extLst>
           </p:cNvPr>
@@ -6580,7 +6580,7 @@
           <p:cNvPr id="8" name="text">
             <a:extLst xmlns:a="http://schemas.openxmlformats.org/drawingml/2006/main">
               <a:ext uri="{FF2B5EF4-FFF2-40B4-BE49-F238E27FC236}">
-                <a16:creationId xmlns:a16="http://schemas.microsoft.com/office/drawing/2014/main" id="{E3B039F9-6290-4D48-8648-4F09AFF1D4AF}"/>
+                <a16:creationId xmlns:a16="http://schemas.microsoft.com/office/drawing/2014/main" id="{AD5D17F1-3D82-4B49-BA11-71667B20BF45}"/>
               </a:ext>
             </a:extLst>
           </p:cNvPr>
@@ -6642,7 +6642,7 @@
           <p:cNvPr id="9" name="text">
             <a:extLst xmlns:a="http://schemas.openxmlformats.org/drawingml/2006/main">
               <a:ext uri="{FF2B5EF4-FFF2-40B4-BE49-F238E27FC236}">
-                <a16:creationId xmlns:a16="http://schemas.microsoft.com/office/drawing/2014/main" id="{E669FE8C-DBCA-42F4-A71C-36A586FA6FDC}"/>
+                <a16:creationId xmlns:a16="http://schemas.microsoft.com/office/drawing/2014/main" id="{F6C852F5-C1D5-4165-B559-D363E019C2B9}"/>
               </a:ext>
             </a:extLst>
           </p:cNvPr>
@@ -6704,7 +6704,7 @@
           <p:cNvPr id="10" name="text">
             <a:extLst xmlns:a="http://schemas.openxmlformats.org/drawingml/2006/main">
               <a:ext uri="{FF2B5EF4-FFF2-40B4-BE49-F238E27FC236}">
-                <a16:creationId xmlns:a16="http://schemas.microsoft.com/office/drawing/2014/main" id="{1AAA10E9-257E-456B-85E5-AFC47AF1AF1C}"/>
+                <a16:creationId xmlns:a16="http://schemas.microsoft.com/office/drawing/2014/main" id="{FB28CE4F-85AF-49F2-8CBF-FFA191B1538C}"/>
               </a:ext>
             </a:extLst>
           </p:cNvPr>
@@ -6766,7 +6766,7 @@
           <p:cNvPr id="11" name="text">
             <a:extLst xmlns:a="http://schemas.openxmlformats.org/drawingml/2006/main">
               <a:ext uri="{FF2B5EF4-FFF2-40B4-BE49-F238E27FC236}">
-                <a16:creationId xmlns:a16="http://schemas.microsoft.com/office/drawing/2014/main" id="{6985E8F7-218C-4D2B-86F1-A4CCE1B61886}"/>
+                <a16:creationId xmlns:a16="http://schemas.microsoft.com/office/drawing/2014/main" id="{C8F766E4-CB2A-48D9-BEA4-B1DE64694907}"/>
               </a:ext>
             </a:extLst>
           </p:cNvPr>
@@ -6880,7 +6880,7 @@
           <p:cNvPr id="14" name="text">
             <a:extLst xmlns:a="http://schemas.openxmlformats.org/drawingml/2006/main">
               <a:ext uri="{FF2B5EF4-FFF2-40B4-BE49-F238E27FC236}">
-                <a16:creationId xmlns:a16="http://schemas.microsoft.com/office/drawing/2014/main" id="{4B7A7364-A164-4230-B819-9E7B67DE998D}"/>
+                <a16:creationId xmlns:a16="http://schemas.microsoft.com/office/drawing/2014/main" id="{F1EEF7D1-AA7D-4776-B3F7-DF30827E8C5B}"/>
               </a:ext>
             </a:extLst>
           </p:cNvPr>
@@ -6942,7 +6942,7 @@
           <p:cNvPr id="15" name="text">
             <a:extLst xmlns:a="http://schemas.openxmlformats.org/drawingml/2006/main">
               <a:ext uri="{FF2B5EF4-FFF2-40B4-BE49-F238E27FC236}">
-                <a16:creationId xmlns:a16="http://schemas.microsoft.com/office/drawing/2014/main" id="{1F3D02A9-F0A4-4870-A0DE-23F27E4EF8CA}"/>
+                <a16:creationId xmlns:a16="http://schemas.microsoft.com/office/drawing/2014/main" id="{58FD7166-563B-45A1-BB60-B945E904D282}"/>
               </a:ext>
             </a:extLst>
           </p:cNvPr>
@@ -7004,7 +7004,7 @@
           <p:cNvPr id="16" name="">
             <a:extLst xmlns:a="http://schemas.openxmlformats.org/drawingml/2006/main">
               <a:ext uri="{FF2B5EF4-FFF2-40B4-BE49-F238E27FC236}">
-                <a16:creationId xmlns:a16="http://schemas.microsoft.com/office/drawing/2014/main" id="{F955B4BF-3462-4C22-8B84-3325A92ABA06}"/>
+                <a16:creationId xmlns:a16="http://schemas.microsoft.com/office/drawing/2014/main" id="{C0ECF02C-7567-479E-A380-885677F8DA0A}"/>
               </a:ext>
             </a:extLst>
           </p:cNvPr>
@@ -7037,7 +7037,7 @@
           <p:cNvPr id="17" name="text">
             <a:extLst xmlns:a="http://schemas.openxmlformats.org/drawingml/2006/main">
               <a:ext uri="{FF2B5EF4-FFF2-40B4-BE49-F238E27FC236}">
-                <a16:creationId xmlns:a16="http://schemas.microsoft.com/office/drawing/2014/main" id="{07B205DF-25B3-4B14-B4AB-3C113C1F3F94}"/>
+                <a16:creationId xmlns:a16="http://schemas.microsoft.com/office/drawing/2014/main" id="{EB51F5DF-BA8C-4A8F-9B91-C1FD24657FD3}"/>
               </a:ext>
             </a:extLst>
           </p:cNvPr>
@@ -7099,7 +7099,7 @@
           <p:cNvPr id="18" name="slide-number">
             <a:extLst xmlns:a="http://schemas.openxmlformats.org/drawingml/2006/main">
               <a:ext uri="{FF2B5EF4-FFF2-40B4-BE49-F238E27FC236}">
-                <a16:creationId xmlns:a16="http://schemas.microsoft.com/office/drawing/2014/main" id="{3164CC01-32CA-421A-8DDB-96615472EB0C}"/>
+                <a16:creationId xmlns:a16="http://schemas.microsoft.com/office/drawing/2014/main" id="{11DB6779-28DC-4268-A345-05EE86F0743C}"/>
               </a:ext>
             </a:extLst>
           </p:cNvPr>
@@ -7159,7 +7159,7 @@
     </p:spTree>
     <p:extLst>
       <p:ext uri="{BB962C8B-B14F-4D97-AF65-F5344CB8AC3E}">
-        <p14:creationId xmlns:p14="http://schemas.microsoft.com/office/powerpoint/2010/main" val="1882856344"/>
+        <p14:creationId xmlns:p14="http://schemas.microsoft.com/office/powerpoint/2010/main" val="73000906"/>
       </p:ext>
     </p:extLst>
   </p:cSld>
@@ -7190,7 +7190,7 @@
           <p:cNvPr id="51" name="title">
             <a:extLst xmlns:a="http://schemas.openxmlformats.org/drawingml/2006/main">
               <a:ext uri="{FF2B5EF4-FFF2-40B4-BE49-F238E27FC236}">
-                <a16:creationId xmlns:a16="http://schemas.microsoft.com/office/drawing/2014/main" id="{B3820029-CCC5-464E-A01B-0F3085080274}"/>
+                <a16:creationId xmlns:a16="http://schemas.microsoft.com/office/drawing/2014/main" id="{49B44925-31DA-478F-A7E5-406191EBEF3E}"/>
               </a:ext>
             </a:extLst>
           </p:cNvPr>
@@ -7252,7 +7252,7 @@
           <p:cNvPr id="2" name="text">
             <a:extLst xmlns:a="http://schemas.openxmlformats.org/drawingml/2006/main">
               <a:ext uri="{FF2B5EF4-FFF2-40B4-BE49-F238E27FC236}">
-                <a16:creationId xmlns:a16="http://schemas.microsoft.com/office/drawing/2014/main" id="{B2E4C8A9-0264-4FBF-BB62-2454F0B36982}"/>
+                <a16:creationId xmlns:a16="http://schemas.microsoft.com/office/drawing/2014/main" id="{B648CE69-F088-4EF9-BABA-438C2D7FE5EF}"/>
               </a:ext>
             </a:extLst>
           </p:cNvPr>
@@ -7314,7 +7314,7 @@
           <p:cNvPr id="3" name="">
             <a:extLst xmlns:a="http://schemas.openxmlformats.org/drawingml/2006/main">
               <a:ext uri="{FF2B5EF4-FFF2-40B4-BE49-F238E27FC236}">
-                <a16:creationId xmlns:a16="http://schemas.microsoft.com/office/drawing/2014/main" id="{06D26FE1-D1B7-43AE-84C7-3A4DCD820642}"/>
+                <a16:creationId xmlns:a16="http://schemas.microsoft.com/office/drawing/2014/main" id="{FA8905D6-B859-4EEC-9931-D889E90C99C9}"/>
               </a:ext>
             </a:extLst>
           </p:cNvPr>
@@ -7358,7 +7358,7 @@
           <p:cNvPr id="4" name="">
             <a:extLst xmlns:a="http://schemas.openxmlformats.org/drawingml/2006/main">
               <a:ext uri="{FF2B5EF4-FFF2-40B4-BE49-F238E27FC236}">
-                <a16:creationId xmlns:a16="http://schemas.microsoft.com/office/drawing/2014/main" id="{C25E2B81-5E9E-4EAE-A333-0C3A0D15AD49}"/>
+                <a16:creationId xmlns:a16="http://schemas.microsoft.com/office/drawing/2014/main" id="{6B4567BE-C496-410C-A2F1-AAC8897D0529}"/>
               </a:ext>
             </a:extLst>
           </p:cNvPr>
@@ -7402,7 +7402,7 @@
           <p:cNvPr id="5" name="">
             <a:extLst xmlns:a="http://schemas.openxmlformats.org/drawingml/2006/main">
               <a:ext uri="{FF2B5EF4-FFF2-40B4-BE49-F238E27FC236}">
-                <a16:creationId xmlns:a16="http://schemas.microsoft.com/office/drawing/2014/main" id="{83F84662-E5E4-480C-B6D4-02D0667FA197}"/>
+                <a16:creationId xmlns:a16="http://schemas.microsoft.com/office/drawing/2014/main" id="{203E4EF8-1294-4E0A-8606-DAE55FC430E3}"/>
               </a:ext>
             </a:extLst>
           </p:cNvPr>
@@ -7446,7 +7446,7 @@
           <p:cNvPr id="6" name="">
             <a:extLst xmlns:a="http://schemas.openxmlformats.org/drawingml/2006/main">
               <a:ext uri="{FF2B5EF4-FFF2-40B4-BE49-F238E27FC236}">
-                <a16:creationId xmlns:a16="http://schemas.microsoft.com/office/drawing/2014/main" id="{352C09C7-D97C-43F0-A825-36EAC2718CC7}"/>
+                <a16:creationId xmlns:a16="http://schemas.microsoft.com/office/drawing/2014/main" id="{3AC91F98-5EAA-411A-A8ED-4476F9D7C05C}"/>
               </a:ext>
             </a:extLst>
           </p:cNvPr>
@@ -7490,7 +7490,7 @@
           <p:cNvPr id="7" name="">
             <a:extLst xmlns:a="http://schemas.openxmlformats.org/drawingml/2006/main">
               <a:ext uri="{FF2B5EF4-FFF2-40B4-BE49-F238E27FC236}">
-                <a16:creationId xmlns:a16="http://schemas.microsoft.com/office/drawing/2014/main" id="{2C15E466-38B3-4592-8D3F-409CB3EF3651}"/>
+                <a16:creationId xmlns:a16="http://schemas.microsoft.com/office/drawing/2014/main" id="{6B83345A-6A09-4F33-B5ED-0AB0ADF62475}"/>
               </a:ext>
             </a:extLst>
           </p:cNvPr>
@@ -7534,7 +7534,7 @@
           <p:cNvPr id="8" name="">
             <a:extLst xmlns:a="http://schemas.openxmlformats.org/drawingml/2006/main">
               <a:ext uri="{FF2B5EF4-FFF2-40B4-BE49-F238E27FC236}">
-                <a16:creationId xmlns:a16="http://schemas.microsoft.com/office/drawing/2014/main" id="{6C201843-8F02-4B1F-B041-A9D050D08933}"/>
+                <a16:creationId xmlns:a16="http://schemas.microsoft.com/office/drawing/2014/main" id="{E6163773-C393-41D2-A9F5-DD1315CC36B3}"/>
               </a:ext>
             </a:extLst>
           </p:cNvPr>
@@ -7578,7 +7578,7 @@
           <p:cNvPr id="9" name="">
             <a:extLst xmlns:a="http://schemas.openxmlformats.org/drawingml/2006/main">
               <a:ext uri="{FF2B5EF4-FFF2-40B4-BE49-F238E27FC236}">
-                <a16:creationId xmlns:a16="http://schemas.microsoft.com/office/drawing/2014/main" id="{20A071DA-0B33-453E-986D-381B62FE90FF}"/>
+                <a16:creationId xmlns:a16="http://schemas.microsoft.com/office/drawing/2014/main" id="{0F35B101-A2A8-47B0-A378-C168EB0BFF04}"/>
               </a:ext>
             </a:extLst>
           </p:cNvPr>
@@ -7622,7 +7622,7 @@
           <p:cNvPr id="10" name="">
             <a:extLst xmlns:a="http://schemas.openxmlformats.org/drawingml/2006/main">
               <a:ext uri="{FF2B5EF4-FFF2-40B4-BE49-F238E27FC236}">
-                <a16:creationId xmlns:a16="http://schemas.microsoft.com/office/drawing/2014/main" id="{26AFA255-66E9-4E46-90F8-C84325894861}"/>
+                <a16:creationId xmlns:a16="http://schemas.microsoft.com/office/drawing/2014/main" id="{1DDA7121-FEDB-4C4D-8B00-89948B7BEEF0}"/>
               </a:ext>
             </a:extLst>
           </p:cNvPr>
@@ -7666,7 +7666,7 @@
           <p:cNvPr id="11" name="">
             <a:extLst xmlns:a="http://schemas.openxmlformats.org/drawingml/2006/main">
               <a:ext uri="{FF2B5EF4-FFF2-40B4-BE49-F238E27FC236}">
-                <a16:creationId xmlns:a16="http://schemas.microsoft.com/office/drawing/2014/main" id="{E4E21EB3-BE12-4642-BACF-E26E9E58379D}"/>
+                <a16:creationId xmlns:a16="http://schemas.microsoft.com/office/drawing/2014/main" id="{CC29CB52-2F5F-46D7-A408-4D084C580862}"/>
               </a:ext>
             </a:extLst>
           </p:cNvPr>
@@ -7710,7 +7710,7 @@
           <p:cNvPr id="12" name="">
             <a:extLst xmlns:a="http://schemas.openxmlformats.org/drawingml/2006/main">
               <a:ext uri="{FF2B5EF4-FFF2-40B4-BE49-F238E27FC236}">
-                <a16:creationId xmlns:a16="http://schemas.microsoft.com/office/drawing/2014/main" id="{FD557984-8A79-498A-B220-7937F8F49D82}"/>
+                <a16:creationId xmlns:a16="http://schemas.microsoft.com/office/drawing/2014/main" id="{7648F324-4E4B-45BD-BFD1-6C240079D231}"/>
               </a:ext>
             </a:extLst>
           </p:cNvPr>
@@ -7754,7 +7754,7 @@
           <p:cNvPr id="13" name="">
             <a:extLst xmlns:a="http://schemas.openxmlformats.org/drawingml/2006/main">
               <a:ext uri="{FF2B5EF4-FFF2-40B4-BE49-F238E27FC236}">
-                <a16:creationId xmlns:a16="http://schemas.microsoft.com/office/drawing/2014/main" id="{1B5841D3-BCA7-4349-AE7F-5BA61041FAB4}"/>
+                <a16:creationId xmlns:a16="http://schemas.microsoft.com/office/drawing/2014/main" id="{23BE0FDE-0A09-49EF-842C-C852AFD070AD}"/>
               </a:ext>
             </a:extLst>
           </p:cNvPr>
@@ -7798,7 +7798,7 @@
           <p:cNvPr id="14" name="">
             <a:extLst xmlns:a="http://schemas.openxmlformats.org/drawingml/2006/main">
               <a:ext uri="{FF2B5EF4-FFF2-40B4-BE49-F238E27FC236}">
-                <a16:creationId xmlns:a16="http://schemas.microsoft.com/office/drawing/2014/main" id="{DBC6596B-8F46-42D3-8242-BA87E1842E39}"/>
+                <a16:creationId xmlns:a16="http://schemas.microsoft.com/office/drawing/2014/main" id="{90D945C5-53CB-41FC-A2FE-8549C93D5ABA}"/>
               </a:ext>
             </a:extLst>
           </p:cNvPr>
@@ -7842,7 +7842,7 @@
           <p:cNvPr id="15" name="">
             <a:extLst xmlns:a="http://schemas.openxmlformats.org/drawingml/2006/main">
               <a:ext uri="{FF2B5EF4-FFF2-40B4-BE49-F238E27FC236}">
-                <a16:creationId xmlns:a16="http://schemas.microsoft.com/office/drawing/2014/main" id="{68D87122-4092-4D53-8D09-623FD9E86D15}"/>
+                <a16:creationId xmlns:a16="http://schemas.microsoft.com/office/drawing/2014/main" id="{49AAFD9E-E095-43D4-A62A-253749A581AD}"/>
               </a:ext>
             </a:extLst>
           </p:cNvPr>
@@ -7886,7 +7886,7 @@
           <p:cNvPr id="16" name="">
             <a:extLst xmlns:a="http://schemas.openxmlformats.org/drawingml/2006/main">
               <a:ext uri="{FF2B5EF4-FFF2-40B4-BE49-F238E27FC236}">
-                <a16:creationId xmlns:a16="http://schemas.microsoft.com/office/drawing/2014/main" id="{1A4DA811-22D9-41E4-835A-26111712ED67}"/>
+                <a16:creationId xmlns:a16="http://schemas.microsoft.com/office/drawing/2014/main" id="{65E6957D-A1CA-4FFE-AEC6-E902C42CC686}"/>
               </a:ext>
             </a:extLst>
           </p:cNvPr>
@@ -7930,7 +7930,7 @@
           <p:cNvPr id="17" name="">
             <a:extLst xmlns:a="http://schemas.openxmlformats.org/drawingml/2006/main">
               <a:ext uri="{FF2B5EF4-FFF2-40B4-BE49-F238E27FC236}">
-                <a16:creationId xmlns:a16="http://schemas.microsoft.com/office/drawing/2014/main" id="{EA3CF4FA-0402-4BF1-BA0A-180C191338B9}"/>
+                <a16:creationId xmlns:a16="http://schemas.microsoft.com/office/drawing/2014/main" id="{672F6F01-1379-4246-8949-C6A4BF3EDF59}"/>
               </a:ext>
             </a:extLst>
           </p:cNvPr>
@@ -7974,7 +7974,7 @@
           <p:cNvPr id="18" name="">
             <a:extLst xmlns:a="http://schemas.openxmlformats.org/drawingml/2006/main">
               <a:ext uri="{FF2B5EF4-FFF2-40B4-BE49-F238E27FC236}">
-                <a16:creationId xmlns:a16="http://schemas.microsoft.com/office/drawing/2014/main" id="{44037E5C-6543-4028-8D6B-F77949D408A4}"/>
+                <a16:creationId xmlns:a16="http://schemas.microsoft.com/office/drawing/2014/main" id="{00805929-7557-4945-A6B4-368154ADEF42}"/>
               </a:ext>
             </a:extLst>
           </p:cNvPr>
@@ -8036,7 +8036,7 @@
           <p:cNvPr id="19" name="text">
             <a:extLst xmlns:a="http://schemas.openxmlformats.org/drawingml/2006/main">
               <a:ext uri="{FF2B5EF4-FFF2-40B4-BE49-F238E27FC236}">
-                <a16:creationId xmlns:a16="http://schemas.microsoft.com/office/drawing/2014/main" id="{D6548088-0E09-4DB6-A2D1-4B7690C68C1D}"/>
+                <a16:creationId xmlns:a16="http://schemas.microsoft.com/office/drawing/2014/main" id="{BA3B2C4C-A112-4BD8-B50E-1FF3A92069EA}"/>
               </a:ext>
             </a:extLst>
           </p:cNvPr>
@@ -8098,7 +8098,7 @@
           <p:cNvPr id="20" name="">
             <a:extLst xmlns:a="http://schemas.openxmlformats.org/drawingml/2006/main">
               <a:ext uri="{FF2B5EF4-FFF2-40B4-BE49-F238E27FC236}">
-                <a16:creationId xmlns:a16="http://schemas.microsoft.com/office/drawing/2014/main" id="{C8611318-4AF3-4E9E-B564-069BE0EB5428}"/>
+                <a16:creationId xmlns:a16="http://schemas.microsoft.com/office/drawing/2014/main" id="{38D75DB4-DC4F-4D0D-B538-1DF34551B09E}"/>
               </a:ext>
             </a:extLst>
           </p:cNvPr>
@@ -8133,7 +8133,7 @@
           <p:cNvPr id="21" name="">
             <a:extLst xmlns:a="http://schemas.openxmlformats.org/drawingml/2006/main">
               <a:ext uri="{FF2B5EF4-FFF2-40B4-BE49-F238E27FC236}">
-                <a16:creationId xmlns:a16="http://schemas.microsoft.com/office/drawing/2014/main" id="{F6FCAFBF-0B67-48F5-BA82-8A29FD473005}"/>
+                <a16:creationId xmlns:a16="http://schemas.microsoft.com/office/drawing/2014/main" id="{854D9727-DCC9-4731-9C91-6F7AF162A81B}"/>
               </a:ext>
             </a:extLst>
           </p:cNvPr>
@@ -8168,7 +8168,7 @@
           <p:cNvPr id="22" name="">
             <a:extLst xmlns:a="http://schemas.openxmlformats.org/drawingml/2006/main">
               <a:ext uri="{FF2B5EF4-FFF2-40B4-BE49-F238E27FC236}">
-                <a16:creationId xmlns:a16="http://schemas.microsoft.com/office/drawing/2014/main" id="{18E1371D-961B-4C89-9308-3A09040DA8CD}"/>
+                <a16:creationId xmlns:a16="http://schemas.microsoft.com/office/drawing/2014/main" id="{DA0951D8-5099-4DA4-B148-3835DF45D7ED}"/>
               </a:ext>
             </a:extLst>
           </p:cNvPr>
@@ -8203,7 +8203,7 @@
           <p:cNvPr id="23" name="">
             <a:extLst xmlns:a="http://schemas.openxmlformats.org/drawingml/2006/main">
               <a:ext uri="{FF2B5EF4-FFF2-40B4-BE49-F238E27FC236}">
-                <a16:creationId xmlns:a16="http://schemas.microsoft.com/office/drawing/2014/main" id="{3616B5CB-C75D-4D49-9557-111CC52EBAB1}"/>
+                <a16:creationId xmlns:a16="http://schemas.microsoft.com/office/drawing/2014/main" id="{C6E5070E-BB00-4844-82B1-339A5F1A5057}"/>
               </a:ext>
             </a:extLst>
           </p:cNvPr>
@@ -8238,7 +8238,7 @@
           <p:cNvPr id="24" name="">
             <a:extLst xmlns:a="http://schemas.openxmlformats.org/drawingml/2006/main">
               <a:ext uri="{FF2B5EF4-FFF2-40B4-BE49-F238E27FC236}">
-                <a16:creationId xmlns:a16="http://schemas.microsoft.com/office/drawing/2014/main" id="{C882419B-1EF3-4C61-9935-0B67320873E9}"/>
+                <a16:creationId xmlns:a16="http://schemas.microsoft.com/office/drawing/2014/main" id="{C2D68B89-0B24-4643-B1F3-E0612AC1197A}"/>
               </a:ext>
             </a:extLst>
           </p:cNvPr>
@@ -8273,7 +8273,7 @@
           <p:cNvPr id="25" name="">
             <a:extLst xmlns:a="http://schemas.openxmlformats.org/drawingml/2006/main">
               <a:ext uri="{FF2B5EF4-FFF2-40B4-BE49-F238E27FC236}">
-                <a16:creationId xmlns:a16="http://schemas.microsoft.com/office/drawing/2014/main" id="{CA34CBBE-6F65-4AB1-A85D-9EA03CEED6A6}"/>
+                <a16:creationId xmlns:a16="http://schemas.microsoft.com/office/drawing/2014/main" id="{CE9F9F2E-D951-4F91-A10F-B908E13DCD4F}"/>
               </a:ext>
             </a:extLst>
           </p:cNvPr>
@@ -8308,7 +8308,7 @@
           <p:cNvPr id="26" name="">
             <a:extLst xmlns:a="http://schemas.openxmlformats.org/drawingml/2006/main">
               <a:ext uri="{FF2B5EF4-FFF2-40B4-BE49-F238E27FC236}">
-                <a16:creationId xmlns:a16="http://schemas.microsoft.com/office/drawing/2014/main" id="{17868631-BA5C-4E2F-9214-0373D75C30C7}"/>
+                <a16:creationId xmlns:a16="http://schemas.microsoft.com/office/drawing/2014/main" id="{2D0D8405-3E6B-42A4-9741-EF8FA3989BE6}"/>
               </a:ext>
             </a:extLst>
           </p:cNvPr>
@@ -8343,7 +8343,7 @@
           <p:cNvPr id="27" name="">
             <a:extLst xmlns:a="http://schemas.openxmlformats.org/drawingml/2006/main">
               <a:ext uri="{FF2B5EF4-FFF2-40B4-BE49-F238E27FC236}">
-                <a16:creationId xmlns:a16="http://schemas.microsoft.com/office/drawing/2014/main" id="{D4CEC129-6760-4747-B0A2-AB5B0DEB43F6}"/>
+                <a16:creationId xmlns:a16="http://schemas.microsoft.com/office/drawing/2014/main" id="{28BE17DD-AB42-4972-80C3-7E3E8FC9241F}"/>
               </a:ext>
             </a:extLst>
           </p:cNvPr>
@@ -8378,7 +8378,7 @@
           <p:cNvPr id="28" name="">
             <a:extLst xmlns:a="http://schemas.openxmlformats.org/drawingml/2006/main">
               <a:ext uri="{FF2B5EF4-FFF2-40B4-BE49-F238E27FC236}">
-                <a16:creationId xmlns:a16="http://schemas.microsoft.com/office/drawing/2014/main" id="{6FE38BB6-8F72-4154-8712-5818E1C11541}"/>
+                <a16:creationId xmlns:a16="http://schemas.microsoft.com/office/drawing/2014/main" id="{A8BF1A9C-8AF6-4144-9CB7-EB1A21006F2D}"/>
               </a:ext>
             </a:extLst>
           </p:cNvPr>
@@ -8413,7 +8413,7 @@
           <p:cNvPr id="29" name="">
             <a:extLst xmlns:a="http://schemas.openxmlformats.org/drawingml/2006/main">
               <a:ext uri="{FF2B5EF4-FFF2-40B4-BE49-F238E27FC236}">
-                <a16:creationId xmlns:a16="http://schemas.microsoft.com/office/drawing/2014/main" id="{D3A3DF15-CD5D-4E8B-823D-BD0CF6EBD411}"/>
+                <a16:creationId xmlns:a16="http://schemas.microsoft.com/office/drawing/2014/main" id="{D211B690-BA09-45F5-AEEC-023BC09A6D29}"/>
               </a:ext>
             </a:extLst>
           </p:cNvPr>
@@ -8448,7 +8448,7 @@
           <p:cNvPr id="30" name="">
             <a:extLst xmlns:a="http://schemas.openxmlformats.org/drawingml/2006/main">
               <a:ext uri="{FF2B5EF4-FFF2-40B4-BE49-F238E27FC236}">
-                <a16:creationId xmlns:a16="http://schemas.microsoft.com/office/drawing/2014/main" id="{26493893-010E-4C85-BE1B-AFA75FB792BD}"/>
+                <a16:creationId xmlns:a16="http://schemas.microsoft.com/office/drawing/2014/main" id="{F7C3FE01-99B4-4C71-99A5-6A8A9397671C}"/>
               </a:ext>
             </a:extLst>
           </p:cNvPr>
@@ -8483,7 +8483,7 @@
           <p:cNvPr id="31" name="">
             <a:extLst xmlns:a="http://schemas.openxmlformats.org/drawingml/2006/main">
               <a:ext uri="{FF2B5EF4-FFF2-40B4-BE49-F238E27FC236}">
-                <a16:creationId xmlns:a16="http://schemas.microsoft.com/office/drawing/2014/main" id="{8D11E319-7585-4295-838D-73C5BF462F38}"/>
+                <a16:creationId xmlns:a16="http://schemas.microsoft.com/office/drawing/2014/main" id="{95E73068-9CB7-4881-BF29-8663F48DEE20}"/>
               </a:ext>
             </a:extLst>
           </p:cNvPr>
@@ -8518,7 +8518,7 @@
           <p:cNvPr id="32" name="">
             <a:extLst xmlns:a="http://schemas.openxmlformats.org/drawingml/2006/main">
               <a:ext uri="{FF2B5EF4-FFF2-40B4-BE49-F238E27FC236}">
-                <a16:creationId xmlns:a16="http://schemas.microsoft.com/office/drawing/2014/main" id="{77737209-63D7-4D63-9FB3-82DCD0FF65FB}"/>
+                <a16:creationId xmlns:a16="http://schemas.microsoft.com/office/drawing/2014/main" id="{1261E7D6-49D2-4CB8-A554-CE11318FB176}"/>
               </a:ext>
             </a:extLst>
           </p:cNvPr>
@@ -8553,7 +8553,7 @@
           <p:cNvPr id="33" name="">
             <a:extLst xmlns:a="http://schemas.openxmlformats.org/drawingml/2006/main">
               <a:ext uri="{FF2B5EF4-FFF2-40B4-BE49-F238E27FC236}">
-                <a16:creationId xmlns:a16="http://schemas.microsoft.com/office/drawing/2014/main" id="{1EB44288-5C84-4D45-ABBB-32B56B67E078}"/>
+                <a16:creationId xmlns:a16="http://schemas.microsoft.com/office/drawing/2014/main" id="{5B67E3AA-CEB5-465A-8DC8-DC9D81C95B68}"/>
               </a:ext>
             </a:extLst>
           </p:cNvPr>
@@ -8588,7 +8588,7 @@
           <p:cNvPr id="34" name="">
             <a:extLst xmlns:a="http://schemas.openxmlformats.org/drawingml/2006/main">
               <a:ext uri="{FF2B5EF4-FFF2-40B4-BE49-F238E27FC236}">
-                <a16:creationId xmlns:a16="http://schemas.microsoft.com/office/drawing/2014/main" id="{08C91EF0-1302-46B1-A8D0-87A31B10150A}"/>
+                <a16:creationId xmlns:a16="http://schemas.microsoft.com/office/drawing/2014/main" id="{FEBF3D70-DB8A-43CC-93A2-58EBDE6AA141}"/>
               </a:ext>
             </a:extLst>
           </p:cNvPr>
@@ -8623,7 +8623,7 @@
           <p:cNvPr id="35" name="">
             <a:extLst xmlns:a="http://schemas.openxmlformats.org/drawingml/2006/main">
               <a:ext uri="{FF2B5EF4-FFF2-40B4-BE49-F238E27FC236}">
-                <a16:creationId xmlns:a16="http://schemas.microsoft.com/office/drawing/2014/main" id="{D97B3E59-C9D0-44E7-881F-8292EACD7B68}"/>
+                <a16:creationId xmlns:a16="http://schemas.microsoft.com/office/drawing/2014/main" id="{3579B091-18C7-4F62-BDA9-6E445C72BFE5}"/>
               </a:ext>
             </a:extLst>
           </p:cNvPr>
@@ -8658,7 +8658,7 @@
           <p:cNvPr id="36" name="">
             <a:extLst xmlns:a="http://schemas.openxmlformats.org/drawingml/2006/main">
               <a:ext uri="{FF2B5EF4-FFF2-40B4-BE49-F238E27FC236}">
-                <a16:creationId xmlns:a16="http://schemas.microsoft.com/office/drawing/2014/main" id="{139885ED-1481-4D86-815B-1B910873DD13}"/>
+                <a16:creationId xmlns:a16="http://schemas.microsoft.com/office/drawing/2014/main" id="{10572A89-8B18-480A-8F07-79CED064DDD0}"/>
               </a:ext>
             </a:extLst>
           </p:cNvPr>
@@ -8693,7 +8693,7 @@
           <p:cNvPr id="37" name="text">
             <a:extLst xmlns:a="http://schemas.openxmlformats.org/drawingml/2006/main">
               <a:ext uri="{FF2B5EF4-FFF2-40B4-BE49-F238E27FC236}">
-                <a16:creationId xmlns:a16="http://schemas.microsoft.com/office/drawing/2014/main" id="{05BA69B4-2C1A-4F0D-8966-4CC7396EB368}"/>
+                <a16:creationId xmlns:a16="http://schemas.microsoft.com/office/drawing/2014/main" id="{C3AE8B94-6A92-416C-8347-5F5382CA9657}"/>
               </a:ext>
             </a:extLst>
           </p:cNvPr>
@@ -8755,7 +8755,7 @@
           <p:cNvPr id="38" name="">
             <a:extLst xmlns:a="http://schemas.openxmlformats.org/drawingml/2006/main">
               <a:ext uri="{FF2B5EF4-FFF2-40B4-BE49-F238E27FC236}">
-                <a16:creationId xmlns:a16="http://schemas.microsoft.com/office/drawing/2014/main" id="{798C17B7-A4CA-4A1D-90FD-C0AE36BD4D9C}"/>
+                <a16:creationId xmlns:a16="http://schemas.microsoft.com/office/drawing/2014/main" id="{47AEBB07-8755-4B15-BE49-A57C72F6E6CB}"/>
               </a:ext>
             </a:extLst>
           </p:cNvPr>
@@ -8788,7 +8788,7 @@
           <p:cNvPr id="39" name="text">
             <a:extLst xmlns:a="http://schemas.openxmlformats.org/drawingml/2006/main">
               <a:ext uri="{FF2B5EF4-FFF2-40B4-BE49-F238E27FC236}">
-                <a16:creationId xmlns:a16="http://schemas.microsoft.com/office/drawing/2014/main" id="{A8D78CBA-4099-4D2D-9C9B-FE27097DFEA4}"/>
+                <a16:creationId xmlns:a16="http://schemas.microsoft.com/office/drawing/2014/main" id="{08E04DA6-E755-49F6-AE9E-BC47E8774316}"/>
               </a:ext>
             </a:extLst>
           </p:cNvPr>
@@ -8850,7 +8850,7 @@
           <p:cNvPr id="40" name="text">
             <a:extLst xmlns:a="http://schemas.openxmlformats.org/drawingml/2006/main">
               <a:ext uri="{FF2B5EF4-FFF2-40B4-BE49-F238E27FC236}">
-                <a16:creationId xmlns:a16="http://schemas.microsoft.com/office/drawing/2014/main" id="{1573AF57-9E9C-4938-9249-E81A041FDC8A}"/>
+                <a16:creationId xmlns:a16="http://schemas.microsoft.com/office/drawing/2014/main" id="{4ADD2BBB-C5FC-4B39-B023-8A0C1D418839}"/>
               </a:ext>
             </a:extLst>
           </p:cNvPr>
@@ -8912,7 +8912,7 @@
           <p:cNvPr id="41" name="text">
             <a:extLst xmlns:a="http://schemas.openxmlformats.org/drawingml/2006/main">
               <a:ext uri="{FF2B5EF4-FFF2-40B4-BE49-F238E27FC236}">
-                <a16:creationId xmlns:a16="http://schemas.microsoft.com/office/drawing/2014/main" id="{E9BD7EE2-E281-4A50-AC91-9E6F12F6637D}"/>
+                <a16:creationId xmlns:a16="http://schemas.microsoft.com/office/drawing/2014/main" id="{415E3BC5-E0C5-4ECA-9210-741AF5AF8138}"/>
               </a:ext>
             </a:extLst>
           </p:cNvPr>
@@ -8974,7 +8974,7 @@
           <p:cNvPr id="42" name="text">
             <a:extLst xmlns:a="http://schemas.openxmlformats.org/drawingml/2006/main">
               <a:ext uri="{FF2B5EF4-FFF2-40B4-BE49-F238E27FC236}">
-                <a16:creationId xmlns:a16="http://schemas.microsoft.com/office/drawing/2014/main" id="{67F3FF3C-766E-4B60-A2ED-2B6F5EFF6237}"/>
+                <a16:creationId xmlns:a16="http://schemas.microsoft.com/office/drawing/2014/main" id="{BF6810B0-540B-4E31-B660-B532DD3DEB1B}"/>
               </a:ext>
             </a:extLst>
           </p:cNvPr>
@@ -9036,7 +9036,7 @@
           <p:cNvPr id="43" name="text">
             <a:extLst xmlns:a="http://schemas.openxmlformats.org/drawingml/2006/main">
               <a:ext uri="{FF2B5EF4-FFF2-40B4-BE49-F238E27FC236}">
-                <a16:creationId xmlns:a16="http://schemas.microsoft.com/office/drawing/2014/main" id="{2A565E7B-D2D2-4B2F-81A1-2429E9FCB090}"/>
+                <a16:creationId xmlns:a16="http://schemas.microsoft.com/office/drawing/2014/main" id="{8072101E-89F5-4B31-9582-789704A7CC8B}"/>
               </a:ext>
             </a:extLst>
           </p:cNvPr>
@@ -9098,7 +9098,7 @@
           <p:cNvPr id="44" name="text">
             <a:extLst xmlns:a="http://schemas.openxmlformats.org/drawingml/2006/main">
               <a:ext uri="{FF2B5EF4-FFF2-40B4-BE49-F238E27FC236}">
-                <a16:creationId xmlns:a16="http://schemas.microsoft.com/office/drawing/2014/main" id="{672C4657-59C0-4731-AF0D-B3820CFB289A}"/>
+                <a16:creationId xmlns:a16="http://schemas.microsoft.com/office/drawing/2014/main" id="{3AE13E54-76D7-4773-9B54-691013E2A9C2}"/>
               </a:ext>
             </a:extLst>
           </p:cNvPr>
@@ -9160,7 +9160,7 @@
           <p:cNvPr id="45" name="text">
             <a:extLst xmlns:a="http://schemas.openxmlformats.org/drawingml/2006/main">
               <a:ext uri="{FF2B5EF4-FFF2-40B4-BE49-F238E27FC236}">
-                <a16:creationId xmlns:a16="http://schemas.microsoft.com/office/drawing/2014/main" id="{C6DE2F97-A0E5-4152-A64D-062AB0FD5454}"/>
+                <a16:creationId xmlns:a16="http://schemas.microsoft.com/office/drawing/2014/main" id="{C80F2004-1FDB-4E6E-B3C9-1840A84F34C7}"/>
               </a:ext>
             </a:extLst>
           </p:cNvPr>
@@ -9222,7 +9222,7 @@
           <p:cNvPr id="46" name="">
             <a:extLst xmlns:a="http://schemas.openxmlformats.org/drawingml/2006/main">
               <a:ext uri="{FF2B5EF4-FFF2-40B4-BE49-F238E27FC236}">
-                <a16:creationId xmlns:a16="http://schemas.microsoft.com/office/drawing/2014/main" id="{B2FEDAB1-DCA7-46FF-818A-4E6FDA851116}"/>
+                <a16:creationId xmlns:a16="http://schemas.microsoft.com/office/drawing/2014/main" id="{0E3AA089-9E2F-4604-84A3-A45D97127349}"/>
               </a:ext>
             </a:extLst>
           </p:cNvPr>
@@ -9255,7 +9255,7 @@
           <p:cNvPr id="47" name="text">
             <a:extLst xmlns:a="http://schemas.openxmlformats.org/drawingml/2006/main">
               <a:ext uri="{FF2B5EF4-FFF2-40B4-BE49-F238E27FC236}">
-                <a16:creationId xmlns:a16="http://schemas.microsoft.com/office/drawing/2014/main" id="{FE1E51D7-B2E0-42D0-A2E7-A70D350DB31D}"/>
+                <a16:creationId xmlns:a16="http://schemas.microsoft.com/office/drawing/2014/main" id="{C49604A5-1891-495D-B6A9-4A178EEFFB4F}"/>
               </a:ext>
             </a:extLst>
           </p:cNvPr>
@@ -9317,7 +9317,7 @@
           <p:cNvPr id="48" name="text">
             <a:extLst xmlns:a="http://schemas.openxmlformats.org/drawingml/2006/main">
               <a:ext uri="{FF2B5EF4-FFF2-40B4-BE49-F238E27FC236}">
-                <a16:creationId xmlns:a16="http://schemas.microsoft.com/office/drawing/2014/main" id="{D283F7AD-4D22-4859-BB8E-0CB6088EC811}"/>
+                <a16:creationId xmlns:a16="http://schemas.microsoft.com/office/drawing/2014/main" id="{20E7A208-2480-4D98-A401-1C6A06B86BA1}"/>
               </a:ext>
             </a:extLst>
           </p:cNvPr>
@@ -9379,7 +9379,7 @@
           <p:cNvPr id="49" name="text">
             <a:extLst xmlns:a="http://schemas.openxmlformats.org/drawingml/2006/main">
               <a:ext uri="{FF2B5EF4-FFF2-40B4-BE49-F238E27FC236}">
-                <a16:creationId xmlns:a16="http://schemas.microsoft.com/office/drawing/2014/main" id="{38DB0471-D3E8-4BEE-9D4E-B707CEE6C364}"/>
+                <a16:creationId xmlns:a16="http://schemas.microsoft.com/office/drawing/2014/main" id="{16B5AE85-6BD2-40A3-96BD-DCD9469D89D4}"/>
               </a:ext>
             </a:extLst>
           </p:cNvPr>
@@ -9431,7 +9431,7 @@
                 <a:ea typeface="Arial"/>
                 <a:cs typeface="Arial"/>
               </a:rPr>
-              <a:t>4,713 requests recovered two blocks in the lab.</a:t>
+              <a:t>3,707 requests recovered two blocks in the lab.</a:t>
             </a:r>
           </a:p>
         </p:txBody>
@@ -9441,7 +9441,7 @@
           <p:cNvPr id="50" name="slide-number">
             <a:extLst xmlns:a="http://schemas.openxmlformats.org/drawingml/2006/main">
               <a:ext uri="{FF2B5EF4-FFF2-40B4-BE49-F238E27FC236}">
-                <a16:creationId xmlns:a16="http://schemas.microsoft.com/office/drawing/2014/main" id="{C05133A2-8AF9-4047-945F-FE3587F74CCC}"/>
+                <a16:creationId xmlns:a16="http://schemas.microsoft.com/office/drawing/2014/main" id="{C7CE85E1-989E-42A3-844E-E02946F647D4}"/>
               </a:ext>
             </a:extLst>
           </p:cNvPr>
@@ -9501,7 +9501,7 @@
     </p:spTree>
     <p:extLst>
       <p:ext uri="{BB962C8B-B14F-4D97-AF65-F5344CB8AC3E}">
-        <p14:creationId xmlns:p14="http://schemas.microsoft.com/office/powerpoint/2010/main" val="332904290"/>
+        <p14:creationId xmlns:p14="http://schemas.microsoft.com/office/powerpoint/2010/main" val="210775687"/>
       </p:ext>
     </p:extLst>
   </p:cSld>
@@ -9532,7 +9532,7 @@
           <p:cNvPr id="16" name="title">
             <a:extLst xmlns:a="http://schemas.openxmlformats.org/drawingml/2006/main">
               <a:ext uri="{FF2B5EF4-FFF2-40B4-BE49-F238E27FC236}">
-                <a16:creationId xmlns:a16="http://schemas.microsoft.com/office/drawing/2014/main" id="{D4A7E877-1C56-479A-8CE4-19AF5383C70F}"/>
+                <a16:creationId xmlns:a16="http://schemas.microsoft.com/office/drawing/2014/main" id="{DE7E323B-A151-46F3-8F65-FD15B89A40D9}"/>
               </a:ext>
             </a:extLst>
           </p:cNvPr>
@@ -9594,7 +9594,7 @@
           <p:cNvPr id="2" name="text">
             <a:extLst xmlns:a="http://schemas.openxmlformats.org/drawingml/2006/main">
               <a:ext uri="{FF2B5EF4-FFF2-40B4-BE49-F238E27FC236}">
-                <a16:creationId xmlns:a16="http://schemas.microsoft.com/office/drawing/2014/main" id="{9CCD9E5F-A70A-4CBF-986D-C6ABDF34AFD9}"/>
+                <a16:creationId xmlns:a16="http://schemas.microsoft.com/office/drawing/2014/main" id="{128A77AC-F307-42E2-BE17-D69C241907C4}"/>
               </a:ext>
             </a:extLst>
           </p:cNvPr>
@@ -9656,7 +9656,7 @@
           <p:cNvPr id="3" name="text">
             <a:extLst xmlns:a="http://schemas.openxmlformats.org/drawingml/2006/main">
               <a:ext uri="{FF2B5EF4-FFF2-40B4-BE49-F238E27FC236}">
-                <a16:creationId xmlns:a16="http://schemas.microsoft.com/office/drawing/2014/main" id="{D02FD05B-F991-416E-9BD2-AFA92B24B826}"/>
+                <a16:creationId xmlns:a16="http://schemas.microsoft.com/office/drawing/2014/main" id="{8F8901F2-C9B4-46E5-9FD0-34FB39D3440E}"/>
               </a:ext>
             </a:extLst>
           </p:cNvPr>
@@ -9718,7 +9718,7 @@
           <p:cNvPr id="4" name="text">
             <a:extLst xmlns:a="http://schemas.openxmlformats.org/drawingml/2006/main">
               <a:ext uri="{FF2B5EF4-FFF2-40B4-BE49-F238E27FC236}">
-                <a16:creationId xmlns:a16="http://schemas.microsoft.com/office/drawing/2014/main" id="{B3D8538F-E166-42E5-983F-CD8C076BD8E9}"/>
+                <a16:creationId xmlns:a16="http://schemas.microsoft.com/office/drawing/2014/main" id="{77E3CC6C-6049-4C48-85CE-3A40FC2928D5}"/>
               </a:ext>
             </a:extLst>
           </p:cNvPr>
@@ -9780,7 +9780,7 @@
           <p:cNvPr id="5" name="text">
             <a:extLst xmlns:a="http://schemas.openxmlformats.org/drawingml/2006/main">
               <a:ext uri="{FF2B5EF4-FFF2-40B4-BE49-F238E27FC236}">
-                <a16:creationId xmlns:a16="http://schemas.microsoft.com/office/drawing/2014/main" id="{44BF383E-68D5-4B67-974B-D0242D8C6083}"/>
+                <a16:creationId xmlns:a16="http://schemas.microsoft.com/office/drawing/2014/main" id="{79000661-E3EC-4218-AC18-F63D5E7B14F5}"/>
               </a:ext>
             </a:extLst>
           </p:cNvPr>
@@ -9842,7 +9842,7 @@
           <p:cNvPr id="6" name="">
             <a:extLst xmlns:a="http://schemas.openxmlformats.org/drawingml/2006/main">
               <a:ext uri="{FF2B5EF4-FFF2-40B4-BE49-F238E27FC236}">
-                <a16:creationId xmlns:a16="http://schemas.microsoft.com/office/drawing/2014/main" id="{C987061C-A163-41F0-9138-060083D86A46}"/>
+                <a16:creationId xmlns:a16="http://schemas.microsoft.com/office/drawing/2014/main" id="{37129F03-43C8-4E1D-A744-05846B3C3EA1}"/>
               </a:ext>
             </a:extLst>
           </p:cNvPr>
@@ -9875,7 +9875,7 @@
           <p:cNvPr id="7" name="text">
             <a:extLst xmlns:a="http://schemas.openxmlformats.org/drawingml/2006/main">
               <a:ext uri="{FF2B5EF4-FFF2-40B4-BE49-F238E27FC236}">
-                <a16:creationId xmlns:a16="http://schemas.microsoft.com/office/drawing/2014/main" id="{B8B51B6E-BF7E-4D9C-B0DC-1A8D546A5D8E}"/>
+                <a16:creationId xmlns:a16="http://schemas.microsoft.com/office/drawing/2014/main" id="{B299E1FB-D48D-407A-BE7C-AF25F362C5B5}"/>
               </a:ext>
             </a:extLst>
           </p:cNvPr>
@@ -9937,7 +9937,7 @@
           <p:cNvPr id="8" name="text">
             <a:extLst xmlns:a="http://schemas.openxmlformats.org/drawingml/2006/main">
               <a:ext uri="{FF2B5EF4-FFF2-40B4-BE49-F238E27FC236}">
-                <a16:creationId xmlns:a16="http://schemas.microsoft.com/office/drawing/2014/main" id="{C6304D45-2D7F-4768-AC9C-798CB7514F30}"/>
+                <a16:creationId xmlns:a16="http://schemas.microsoft.com/office/drawing/2014/main" id="{EF146E8C-DA5A-4002-90C3-C02B4BDFFD45}"/>
               </a:ext>
             </a:extLst>
           </p:cNvPr>
@@ -9999,7 +9999,7 @@
           <p:cNvPr id="9" name="">
             <a:extLst xmlns:a="http://schemas.openxmlformats.org/drawingml/2006/main">
               <a:ext uri="{FF2B5EF4-FFF2-40B4-BE49-F238E27FC236}">
-                <a16:creationId xmlns:a16="http://schemas.microsoft.com/office/drawing/2014/main" id="{EA7525BC-DB11-4582-8743-CFB9AA73E332}"/>
+                <a16:creationId xmlns:a16="http://schemas.microsoft.com/office/drawing/2014/main" id="{1968EBC2-BE8B-495E-A591-06164992EC61}"/>
               </a:ext>
             </a:extLst>
           </p:cNvPr>
@@ -10034,7 +10034,7 @@
           <p:cNvPr id="10" name="text">
             <a:extLst xmlns:a="http://schemas.openxmlformats.org/drawingml/2006/main">
               <a:ext uri="{FF2B5EF4-FFF2-40B4-BE49-F238E27FC236}">
-                <a16:creationId xmlns:a16="http://schemas.microsoft.com/office/drawing/2014/main" id="{27E809F1-C17E-4D3F-B7EB-E47131C2B98B}"/>
+                <a16:creationId xmlns:a16="http://schemas.microsoft.com/office/drawing/2014/main" id="{7A69ABB4-B3C6-4FFE-B472-604FCE151F2B}"/>
               </a:ext>
             </a:extLst>
           </p:cNvPr>
@@ -10096,7 +10096,7 @@
           <p:cNvPr id="11" name="text">
             <a:extLst xmlns:a="http://schemas.openxmlformats.org/drawingml/2006/main">
               <a:ext uri="{FF2B5EF4-FFF2-40B4-BE49-F238E27FC236}">
-                <a16:creationId xmlns:a16="http://schemas.microsoft.com/office/drawing/2014/main" id="{7F93FC52-AF4A-4E97-9939-0DC0A8F81EAC}"/>
+                <a16:creationId xmlns:a16="http://schemas.microsoft.com/office/drawing/2014/main" id="{730457A5-90C1-4A83-9EF7-4211DBF6F771}"/>
               </a:ext>
             </a:extLst>
           </p:cNvPr>
@@ -10158,7 +10158,7 @@
           <p:cNvPr id="12" name="text">
             <a:extLst xmlns:a="http://schemas.openxmlformats.org/drawingml/2006/main">
               <a:ext uri="{FF2B5EF4-FFF2-40B4-BE49-F238E27FC236}">
-                <a16:creationId xmlns:a16="http://schemas.microsoft.com/office/drawing/2014/main" id="{35A70FEB-BBC8-4F86-B8F9-F5F0B6570A88}"/>
+                <a16:creationId xmlns:a16="http://schemas.microsoft.com/office/drawing/2014/main" id="{96B2B3A4-CBC4-4C87-8F30-4ED7C96C5185}"/>
               </a:ext>
             </a:extLst>
           </p:cNvPr>
@@ -10220,7 +10220,7 @@
           <p:cNvPr id="13" name="text">
             <a:extLst xmlns:a="http://schemas.openxmlformats.org/drawingml/2006/main">
               <a:ext uri="{FF2B5EF4-FFF2-40B4-BE49-F238E27FC236}">
-                <a16:creationId xmlns:a16="http://schemas.microsoft.com/office/drawing/2014/main" id="{7C41C83E-2A56-440D-A8E8-4BAD76BF6340}"/>
+                <a16:creationId xmlns:a16="http://schemas.microsoft.com/office/drawing/2014/main" id="{E52EF5EA-DFCC-4004-BD16-38D2C69B3564}"/>
               </a:ext>
             </a:extLst>
           </p:cNvPr>
@@ -10282,7 +10282,7 @@
           <p:cNvPr id="14" name="text">
             <a:extLst xmlns:a="http://schemas.openxmlformats.org/drawingml/2006/main">
               <a:ext uri="{FF2B5EF4-FFF2-40B4-BE49-F238E27FC236}">
-                <a16:creationId xmlns:a16="http://schemas.microsoft.com/office/drawing/2014/main" id="{15F2DA96-BA08-4F1D-996E-F4AAA27B076D}"/>
+                <a16:creationId xmlns:a16="http://schemas.microsoft.com/office/drawing/2014/main" id="{E3BD2D13-7A89-4EF2-AC35-1EEAA61ABEC8}"/>
               </a:ext>
             </a:extLst>
           </p:cNvPr>
@@ -10344,7 +10344,7 @@
           <p:cNvPr id="15" name="slide-number">
             <a:extLst xmlns:a="http://schemas.openxmlformats.org/drawingml/2006/main">
               <a:ext uri="{FF2B5EF4-FFF2-40B4-BE49-F238E27FC236}">
-                <a16:creationId xmlns:a16="http://schemas.microsoft.com/office/drawing/2014/main" id="{E970B322-35A0-4600-A3B6-DF307B84FD54}"/>
+                <a16:creationId xmlns:a16="http://schemas.microsoft.com/office/drawing/2014/main" id="{A4AB4C0F-D71E-4DBB-B30B-018321E8DDFE}"/>
               </a:ext>
             </a:extLst>
           </p:cNvPr>
@@ -10404,7 +10404,7 @@
     </p:spTree>
     <p:extLst>
       <p:ext uri="{BB962C8B-B14F-4D97-AF65-F5344CB8AC3E}">
-        <p14:creationId xmlns:p14="http://schemas.microsoft.com/office/powerpoint/2010/main" val="47360706"/>
+        <p14:creationId xmlns:p14="http://schemas.microsoft.com/office/powerpoint/2010/main" val="771365706"/>
       </p:ext>
     </p:extLst>
   </p:cSld>
@@ -10435,7 +10435,7 @@
           <p:cNvPr id="5" name="title">
             <a:extLst xmlns:a="http://schemas.openxmlformats.org/drawingml/2006/main">
               <a:ext uri="{FF2B5EF4-FFF2-40B4-BE49-F238E27FC236}">
-                <a16:creationId xmlns:a16="http://schemas.microsoft.com/office/drawing/2014/main" id="{E5809E86-00BB-4C31-8B4D-0C9FECA4F3E0}"/>
+                <a16:creationId xmlns:a16="http://schemas.microsoft.com/office/drawing/2014/main" id="{8BD6CFDC-E121-439A-8732-64CB0C7B015C}"/>
               </a:ext>
             </a:extLst>
           </p:cNvPr>
@@ -10497,7 +10497,7 @@
           <p:cNvPr id="2" name="text">
             <a:extLst xmlns:a="http://schemas.openxmlformats.org/drawingml/2006/main">
               <a:ext uri="{FF2B5EF4-FFF2-40B4-BE49-F238E27FC236}">
-                <a16:creationId xmlns:a16="http://schemas.microsoft.com/office/drawing/2014/main" id="{A606D73D-2104-4E03-8A8B-B6EDAAC8F25F}"/>
+                <a16:creationId xmlns:a16="http://schemas.microsoft.com/office/drawing/2014/main" id="{6FCBCA68-9184-4ED9-9EDD-87E1C197676B}"/>
               </a:ext>
             </a:extLst>
           </p:cNvPr>
@@ -10563,7 +10563,7 @@
           <p:nvPr/>
         </p:nvPicPr>
         <p:blipFill>
-          <a:blip xmlns:r="http://schemas.openxmlformats.org/officeDocument/2006/relationships" xmlns:a="http://schemas.openxmlformats.org/drawingml/2006/main" r:embed="R020d452f07144a41"/>
+          <a:blip xmlns:r="http://schemas.openxmlformats.org/officeDocument/2006/relationships" xmlns:a="http://schemas.openxmlformats.org/drawingml/2006/main" r:embed="Rbcc5299344ba48c0"/>
           <a:stretch xmlns:a="http://schemas.openxmlformats.org/drawingml/2006/main"/>
         </p:blipFill>
         <p:spPr>
@@ -10581,7 +10581,7 @@
           <p:cNvPr id="4" name="slide-number">
             <a:extLst xmlns:a="http://schemas.openxmlformats.org/drawingml/2006/main">
               <a:ext uri="{FF2B5EF4-FFF2-40B4-BE49-F238E27FC236}">
-                <a16:creationId xmlns:a16="http://schemas.microsoft.com/office/drawing/2014/main" id="{CFCF50DE-AA2B-4838-AE34-565BF6DBC652}"/>
+                <a16:creationId xmlns:a16="http://schemas.microsoft.com/office/drawing/2014/main" id="{04DDC993-AA4E-44CD-95C6-87D05C9731E0}"/>
               </a:ext>
             </a:extLst>
           </p:cNvPr>
@@ -10641,7 +10641,7 @@
     </p:spTree>
     <p:extLst>
       <p:ext uri="{BB962C8B-B14F-4D97-AF65-F5344CB8AC3E}">
-        <p14:creationId xmlns:p14="http://schemas.microsoft.com/office/powerpoint/2010/main" val="345036811"/>
+        <p14:creationId xmlns:p14="http://schemas.microsoft.com/office/powerpoint/2010/main" val="1736271499"/>
       </p:ext>
     </p:extLst>
   </p:cSld>
@@ -10672,7 +10672,7 @@
           <p:cNvPr id="20" name="title">
             <a:extLst xmlns:a="http://schemas.openxmlformats.org/drawingml/2006/main">
               <a:ext uri="{FF2B5EF4-FFF2-40B4-BE49-F238E27FC236}">
-                <a16:creationId xmlns:a16="http://schemas.microsoft.com/office/drawing/2014/main" id="{C3A420EC-4469-4FCD-BB50-DFBD997B6A2E}"/>
+                <a16:creationId xmlns:a16="http://schemas.microsoft.com/office/drawing/2014/main" id="{B2136E1F-32F2-4581-A790-1B8CB210E2CD}"/>
               </a:ext>
             </a:extLst>
           </p:cNvPr>
@@ -10734,7 +10734,7 @@
           <p:cNvPr id="2" name="text">
             <a:extLst xmlns:a="http://schemas.openxmlformats.org/drawingml/2006/main">
               <a:ext uri="{FF2B5EF4-FFF2-40B4-BE49-F238E27FC236}">
-                <a16:creationId xmlns:a16="http://schemas.microsoft.com/office/drawing/2014/main" id="{608ED0AD-01CC-4CC3-95E7-8A137AEF50E3}"/>
+                <a16:creationId xmlns:a16="http://schemas.microsoft.com/office/drawing/2014/main" id="{C275AF1E-D5EA-439E-8588-9D700BAFC889}"/>
               </a:ext>
             </a:extLst>
           </p:cNvPr>
@@ -10786,7 +10786,7 @@
                 <a:ea typeface="Arial"/>
                 <a:cs typeface="Arial"/>
               </a:rPr>
-              <a:t>Synthetic localhost session  /  no real user data</a:t>
+              <a:t>Synthetic localhost session  /  refreshed evidence run  /  no real user data</a:t>
             </a:r>
           </a:p>
         </p:txBody>
@@ -10796,7 +10796,7 @@
           <p:cNvPr id="3" name="text">
             <a:extLst xmlns:a="http://schemas.openxmlformats.org/drawingml/2006/main">
               <a:ext uri="{FF2B5EF4-FFF2-40B4-BE49-F238E27FC236}">
-                <a16:creationId xmlns:a16="http://schemas.microsoft.com/office/drawing/2014/main" id="{9DC3C483-307F-4B5B-9F3C-390A805FD4F6}"/>
+                <a16:creationId xmlns:a16="http://schemas.microsoft.com/office/drawing/2014/main" id="{352D4A55-7828-44BE-BFF4-CA328BC91678}"/>
               </a:ext>
             </a:extLst>
           </p:cNvPr>
@@ -10858,7 +10858,7 @@
           <p:cNvPr id="4" name="text">
             <a:extLst xmlns:a="http://schemas.openxmlformats.org/drawingml/2006/main">
               <a:ext uri="{FF2B5EF4-FFF2-40B4-BE49-F238E27FC236}">
-                <a16:creationId xmlns:a16="http://schemas.microsoft.com/office/drawing/2014/main" id="{4CAD1AB4-A8BF-4619-8EC9-545828FFD0A3}"/>
+                <a16:creationId xmlns:a16="http://schemas.microsoft.com/office/drawing/2014/main" id="{914BFC87-D986-4D3E-A88A-B8768F9C00A0}"/>
               </a:ext>
             </a:extLst>
           </p:cNvPr>
@@ -10920,7 +10920,7 @@
           <p:cNvPr id="5" name="">
             <a:extLst xmlns:a="http://schemas.openxmlformats.org/drawingml/2006/main">
               <a:ext uri="{FF2B5EF4-FFF2-40B4-BE49-F238E27FC236}">
-                <a16:creationId xmlns:a16="http://schemas.microsoft.com/office/drawing/2014/main" id="{264FB251-46EB-4004-9D79-AD30CA3ABAFA}"/>
+                <a16:creationId xmlns:a16="http://schemas.microsoft.com/office/drawing/2014/main" id="{E8C1FD4B-E8F1-4753-89C3-54B01B02FA4F}"/>
               </a:ext>
             </a:extLst>
           </p:cNvPr>
@@ -10953,7 +10953,7 @@
           <p:cNvPr id="6" name="text">
             <a:extLst xmlns:a="http://schemas.openxmlformats.org/drawingml/2006/main">
               <a:ext uri="{FF2B5EF4-FFF2-40B4-BE49-F238E27FC236}">
-                <a16:creationId xmlns:a16="http://schemas.microsoft.com/office/drawing/2014/main" id="{C1C107D0-521B-4AC4-89BC-B7DE2B435CC5}"/>
+                <a16:creationId xmlns:a16="http://schemas.microsoft.com/office/drawing/2014/main" id="{4389EE21-6609-4403-A0C6-2EDBB9506E70}"/>
               </a:ext>
             </a:extLst>
           </p:cNvPr>
@@ -11015,7 +11015,7 @@
           <p:cNvPr id="7" name="text">
             <a:extLst xmlns:a="http://schemas.openxmlformats.org/drawingml/2006/main">
               <a:ext uri="{FF2B5EF4-FFF2-40B4-BE49-F238E27FC236}">
-                <a16:creationId xmlns:a16="http://schemas.microsoft.com/office/drawing/2014/main" id="{E8181A55-893D-4C4D-A5C6-8E61DF7B19A2}"/>
+                <a16:creationId xmlns:a16="http://schemas.microsoft.com/office/drawing/2014/main" id="{0D8C29B1-0F15-4C4A-BE71-B820DDB073FF}"/>
               </a:ext>
             </a:extLst>
           </p:cNvPr>
@@ -11077,7 +11077,7 @@
           <p:cNvPr id="8" name="">
             <a:extLst xmlns:a="http://schemas.openxmlformats.org/drawingml/2006/main">
               <a:ext uri="{FF2B5EF4-FFF2-40B4-BE49-F238E27FC236}">
-                <a16:creationId xmlns:a16="http://schemas.microsoft.com/office/drawing/2014/main" id="{FEB52B58-4FDA-4EC5-B79D-C5461136EFEF}"/>
+                <a16:creationId xmlns:a16="http://schemas.microsoft.com/office/drawing/2014/main" id="{9A06164C-BC72-416D-B57C-6C813B1FCA47}"/>
               </a:ext>
             </a:extLst>
           </p:cNvPr>
@@ -11110,7 +11110,7 @@
           <p:cNvPr id="9" name="text">
             <a:extLst xmlns:a="http://schemas.openxmlformats.org/drawingml/2006/main">
               <a:ext uri="{FF2B5EF4-FFF2-40B4-BE49-F238E27FC236}">
-                <a16:creationId xmlns:a16="http://schemas.microsoft.com/office/drawing/2014/main" id="{59310F39-F8E0-4E5B-ADF0-2D1C29A4C53B}"/>
+                <a16:creationId xmlns:a16="http://schemas.microsoft.com/office/drawing/2014/main" id="{FDBB8908-63F7-495A-97CE-29690544D553}"/>
               </a:ext>
             </a:extLst>
           </p:cNvPr>
@@ -11172,7 +11172,7 @@
           <p:cNvPr id="10" name="text">
             <a:extLst xmlns:a="http://schemas.openxmlformats.org/drawingml/2006/main">
               <a:ext uri="{FF2B5EF4-FFF2-40B4-BE49-F238E27FC236}">
-                <a16:creationId xmlns:a16="http://schemas.microsoft.com/office/drawing/2014/main" id="{4691216F-B027-475F-B34E-614B5F741D2D}"/>
+                <a16:creationId xmlns:a16="http://schemas.microsoft.com/office/drawing/2014/main" id="{98F8B332-6CC1-4AA2-9775-18DDB0433DA9}"/>
               </a:ext>
             </a:extLst>
           </p:cNvPr>
@@ -11234,7 +11234,7 @@
           <p:cNvPr id="11" name="">
             <a:extLst xmlns:a="http://schemas.openxmlformats.org/drawingml/2006/main">
               <a:ext uri="{FF2B5EF4-FFF2-40B4-BE49-F238E27FC236}">
-                <a16:creationId xmlns:a16="http://schemas.microsoft.com/office/drawing/2014/main" id="{F8E497D6-8395-4EB4-8373-67FF1F64C41F}"/>
+                <a16:creationId xmlns:a16="http://schemas.microsoft.com/office/drawing/2014/main" id="{513B60CD-F58E-475C-A90D-095AA5521F5E}"/>
               </a:ext>
             </a:extLst>
           </p:cNvPr>
@@ -11267,7 +11267,7 @@
           <p:cNvPr id="12" name="text">
             <a:extLst xmlns:a="http://schemas.openxmlformats.org/drawingml/2006/main">
               <a:ext uri="{FF2B5EF4-FFF2-40B4-BE49-F238E27FC236}">
-                <a16:creationId xmlns:a16="http://schemas.microsoft.com/office/drawing/2014/main" id="{ABF62E37-FDCF-405D-8486-7E7D133B6244}"/>
+                <a16:creationId xmlns:a16="http://schemas.microsoft.com/office/drawing/2014/main" id="{9DB1F8D3-1ECB-4628-924D-464495D39A5F}"/>
               </a:ext>
             </a:extLst>
           </p:cNvPr>
@@ -11329,7 +11329,7 @@
           <p:cNvPr id="13" name="text">
             <a:extLst xmlns:a="http://schemas.openxmlformats.org/drawingml/2006/main">
               <a:ext uri="{FF2B5EF4-FFF2-40B4-BE49-F238E27FC236}">
-                <a16:creationId xmlns:a16="http://schemas.microsoft.com/office/drawing/2014/main" id="{A87826C2-D46A-4318-8DDA-FD965006219C}"/>
+                <a16:creationId xmlns:a16="http://schemas.microsoft.com/office/drawing/2014/main" id="{C175F7FD-8F75-47BD-9379-72EE426F4A9E}"/>
               </a:ext>
             </a:extLst>
           </p:cNvPr>
@@ -11391,7 +11391,7 @@
           <p:cNvPr id="14" name="text">
             <a:extLst xmlns:a="http://schemas.openxmlformats.org/drawingml/2006/main">
               <a:ext uri="{FF2B5EF4-FFF2-40B4-BE49-F238E27FC236}">
-                <a16:creationId xmlns:a16="http://schemas.microsoft.com/office/drawing/2014/main" id="{E62E2918-3563-428E-AC86-13BF4DC2A2E2}"/>
+                <a16:creationId xmlns:a16="http://schemas.microsoft.com/office/drawing/2014/main" id="{FB6E80A0-F3F7-4D0B-9D1C-D34C0CEACE07}"/>
               </a:ext>
             </a:extLst>
           </p:cNvPr>
@@ -11443,7 +11443,7 @@
                 <a:ea typeface="Arial"/>
                 <a:cs typeface="Arial"/>
               </a:rPr>
-              <a:t>4,713</a:t>
+              <a:t>3,707</a:t>
             </a:r>
           </a:p>
         </p:txBody>
@@ -11453,7 +11453,7 @@
           <p:cNvPr id="15" name="text">
             <a:extLst xmlns:a="http://schemas.openxmlformats.org/drawingml/2006/main">
               <a:ext uri="{FF2B5EF4-FFF2-40B4-BE49-F238E27FC236}">
-                <a16:creationId xmlns:a16="http://schemas.microsoft.com/office/drawing/2014/main" id="{9876B698-2882-4D51-8BB5-8326B3097DC8}"/>
+                <a16:creationId xmlns:a16="http://schemas.microsoft.com/office/drawing/2014/main" id="{269E4D0D-70F3-400F-9166-088F5D33D677}"/>
               </a:ext>
             </a:extLst>
           </p:cNvPr>
@@ -11515,7 +11515,7 @@
           <p:cNvPr id="16" name="text">
             <a:extLst xmlns:a="http://schemas.openxmlformats.org/drawingml/2006/main">
               <a:ext uri="{FF2B5EF4-FFF2-40B4-BE49-F238E27FC236}">
-                <a16:creationId xmlns:a16="http://schemas.microsoft.com/office/drawing/2014/main" id="{520F7ACA-9997-43E0-8BC7-4C3D0873BA6B}"/>
+                <a16:creationId xmlns:a16="http://schemas.microsoft.com/office/drawing/2014/main" id="{3FE08177-2A79-4F45-9A77-83E335B9EEE9}"/>
               </a:ext>
             </a:extLst>
           </p:cNvPr>
@@ -11577,7 +11577,7 @@
           <p:cNvPr id="17" name="text">
             <a:extLst xmlns:a="http://schemas.openxmlformats.org/drawingml/2006/main">
               <a:ext uri="{FF2B5EF4-FFF2-40B4-BE49-F238E27FC236}">
-                <a16:creationId xmlns:a16="http://schemas.microsoft.com/office/drawing/2014/main" id="{E5A67132-7E5D-4487-9E6E-B12478C8F7A9}"/>
+                <a16:creationId xmlns:a16="http://schemas.microsoft.com/office/drawing/2014/main" id="{749F5FCB-90E4-4C3D-B9D3-856A7DA57772}"/>
               </a:ext>
             </a:extLst>
           </p:cNvPr>
@@ -11639,7 +11639,7 @@
           <p:cNvPr id="18" name="text">
             <a:extLst xmlns:a="http://schemas.openxmlformats.org/drawingml/2006/main">
               <a:ext uri="{FF2B5EF4-FFF2-40B4-BE49-F238E27FC236}">
-                <a16:creationId xmlns:a16="http://schemas.microsoft.com/office/drawing/2014/main" id="{8F696BD5-E7A8-4EDA-97C6-2E3C379329C0}"/>
+                <a16:creationId xmlns:a16="http://schemas.microsoft.com/office/drawing/2014/main" id="{630B4BE5-35A7-4E0A-8211-755FF8AFF24F}"/>
               </a:ext>
             </a:extLst>
           </p:cNvPr>
@@ -11701,7 +11701,7 @@
           <p:cNvPr id="19" name="slide-number">
             <a:extLst xmlns:a="http://schemas.openxmlformats.org/drawingml/2006/main">
               <a:ext uri="{FF2B5EF4-FFF2-40B4-BE49-F238E27FC236}">
-                <a16:creationId xmlns:a16="http://schemas.microsoft.com/office/drawing/2014/main" id="{107D5A2E-70C4-432F-8292-2E5C4F19BDA6}"/>
+                <a16:creationId xmlns:a16="http://schemas.microsoft.com/office/drawing/2014/main" id="{B694E3E2-7344-4161-B6B5-53C06CEFED70}"/>
               </a:ext>
             </a:extLst>
           </p:cNvPr>
@@ -11761,7 +11761,7 @@
     </p:spTree>
     <p:extLst>
       <p:ext uri="{BB962C8B-B14F-4D97-AF65-F5344CB8AC3E}">
-        <p14:creationId xmlns:p14="http://schemas.microsoft.com/office/powerpoint/2010/main" val="950158173"/>
+        <p14:creationId xmlns:p14="http://schemas.microsoft.com/office/powerpoint/2010/main" val="612910811"/>
       </p:ext>
     </p:extLst>
   </p:cSld>
@@ -11792,7 +11792,7 @@
           <p:cNvPr id="21" name="title">
             <a:extLst xmlns:a="http://schemas.openxmlformats.org/drawingml/2006/main">
               <a:ext uri="{FF2B5EF4-FFF2-40B4-BE49-F238E27FC236}">
-                <a16:creationId xmlns:a16="http://schemas.microsoft.com/office/drawing/2014/main" id="{5AFC9E9D-E9C6-482D-B6F1-89C7BEBD37A5}"/>
+                <a16:creationId xmlns:a16="http://schemas.microsoft.com/office/drawing/2014/main" id="{2151FB1D-B1E2-4BA4-978F-2BA1335201BE}"/>
               </a:ext>
             </a:extLst>
           </p:cNvPr>
@@ -11854,7 +11854,7 @@
           <p:cNvPr id="2" name="text">
             <a:extLst xmlns:a="http://schemas.openxmlformats.org/drawingml/2006/main">
               <a:ext uri="{FF2B5EF4-FFF2-40B4-BE49-F238E27FC236}">
-                <a16:creationId xmlns:a16="http://schemas.microsoft.com/office/drawing/2014/main" id="{9D7F6E18-2D62-486E-A391-A14C70295096}"/>
+                <a16:creationId xmlns:a16="http://schemas.microsoft.com/office/drawing/2014/main" id="{9499CCFF-A6AC-4F83-A46E-60F80B1811BF}"/>
               </a:ext>
             </a:extLst>
           </p:cNvPr>
@@ -11916,7 +11916,7 @@
           <p:cNvPr id="3" name="">
             <a:extLst xmlns:a="http://schemas.openxmlformats.org/drawingml/2006/main">
               <a:ext uri="{FF2B5EF4-FFF2-40B4-BE49-F238E27FC236}">
-                <a16:creationId xmlns:a16="http://schemas.microsoft.com/office/drawing/2014/main" id="{9BA7BAEF-7123-424E-8466-B9457ABB9A45}"/>
+                <a16:creationId xmlns:a16="http://schemas.microsoft.com/office/drawing/2014/main" id="{1DFC4630-BA9A-4555-A041-11C0BF75547F}"/>
               </a:ext>
             </a:extLst>
           </p:cNvPr>
@@ -11949,7 +11949,7 @@
           <p:cNvPr id="4" name="text">
             <a:extLst xmlns:a="http://schemas.openxmlformats.org/drawingml/2006/main">
               <a:ext uri="{FF2B5EF4-FFF2-40B4-BE49-F238E27FC236}">
-                <a16:creationId xmlns:a16="http://schemas.microsoft.com/office/drawing/2014/main" id="{95A34442-7F59-4808-953C-FD9ED2FE0240}"/>
+                <a16:creationId xmlns:a16="http://schemas.microsoft.com/office/drawing/2014/main" id="{1FAA4F2C-DBF3-4508-B050-0BD471CB73B9}"/>
               </a:ext>
             </a:extLst>
           </p:cNvPr>
@@ -12011,7 +12011,7 @@
           <p:cNvPr id="5" name="text">
             <a:extLst xmlns:a="http://schemas.openxmlformats.org/drawingml/2006/main">
               <a:ext uri="{FF2B5EF4-FFF2-40B4-BE49-F238E27FC236}">
-                <a16:creationId xmlns:a16="http://schemas.microsoft.com/office/drawing/2014/main" id="{CCC36D98-738B-4858-997F-30DEB88E2ACF}"/>
+                <a16:creationId xmlns:a16="http://schemas.microsoft.com/office/drawing/2014/main" id="{68EC1563-BED5-4E0F-B62E-A4572EE8E017}"/>
               </a:ext>
             </a:extLst>
           </p:cNvPr>
@@ -12073,7 +12073,7 @@
           <p:cNvPr id="6" name="text">
             <a:extLst xmlns:a="http://schemas.openxmlformats.org/drawingml/2006/main">
               <a:ext uri="{FF2B5EF4-FFF2-40B4-BE49-F238E27FC236}">
-                <a16:creationId xmlns:a16="http://schemas.microsoft.com/office/drawing/2014/main" id="{5A896605-4CF1-4443-B886-480A8498B119}"/>
+                <a16:creationId xmlns:a16="http://schemas.microsoft.com/office/drawing/2014/main" id="{C6C37428-5CA7-4DD2-B661-36A5249C9BEF}"/>
               </a:ext>
             </a:extLst>
           </p:cNvPr>
@@ -12135,7 +12135,7 @@
           <p:cNvPr id="7" name="">
             <a:extLst xmlns:a="http://schemas.openxmlformats.org/drawingml/2006/main">
               <a:ext uri="{FF2B5EF4-FFF2-40B4-BE49-F238E27FC236}">
-                <a16:creationId xmlns:a16="http://schemas.microsoft.com/office/drawing/2014/main" id="{E5D5192D-D75A-41C4-85B3-8C89229AFF3D}"/>
+                <a16:creationId xmlns:a16="http://schemas.microsoft.com/office/drawing/2014/main" id="{4830A8C1-0613-4EFE-832D-91B8E0AD1EC6}"/>
               </a:ext>
             </a:extLst>
           </p:cNvPr>
@@ -12168,7 +12168,7 @@
           <p:cNvPr id="8" name="">
             <a:extLst xmlns:a="http://schemas.openxmlformats.org/drawingml/2006/main">
               <a:ext uri="{FF2B5EF4-FFF2-40B4-BE49-F238E27FC236}">
-                <a16:creationId xmlns:a16="http://schemas.microsoft.com/office/drawing/2014/main" id="{E44AE5C6-D7F6-42B8-AF2B-FC522880AC86}"/>
+                <a16:creationId xmlns:a16="http://schemas.microsoft.com/office/drawing/2014/main" id="{CE252E73-D36A-4636-B028-49A3DCB2128E}"/>
               </a:ext>
             </a:extLst>
           </p:cNvPr>
@@ -12201,7 +12201,7 @@
           <p:cNvPr id="9" name="text">
             <a:extLst xmlns:a="http://schemas.openxmlformats.org/drawingml/2006/main">
               <a:ext uri="{FF2B5EF4-FFF2-40B4-BE49-F238E27FC236}">
-                <a16:creationId xmlns:a16="http://schemas.microsoft.com/office/drawing/2014/main" id="{33476DE4-5C45-444C-91E4-9074B0EBC321}"/>
+                <a16:creationId xmlns:a16="http://schemas.microsoft.com/office/drawing/2014/main" id="{7007852F-5714-45A2-AD42-46F9A74074BC}"/>
               </a:ext>
             </a:extLst>
           </p:cNvPr>
@@ -12263,7 +12263,7 @@
           <p:cNvPr id="10" name="text">
             <a:extLst xmlns:a="http://schemas.openxmlformats.org/drawingml/2006/main">
               <a:ext uri="{FF2B5EF4-FFF2-40B4-BE49-F238E27FC236}">
-                <a16:creationId xmlns:a16="http://schemas.microsoft.com/office/drawing/2014/main" id="{DBFD94E7-FE7D-4244-8946-3E3065881082}"/>
+                <a16:creationId xmlns:a16="http://schemas.microsoft.com/office/drawing/2014/main" id="{BC36219B-79B0-4B35-824C-BBE3DE08833D}"/>
               </a:ext>
             </a:extLst>
           </p:cNvPr>
@@ -12325,7 +12325,7 @@
           <p:cNvPr id="11" name="text">
             <a:extLst xmlns:a="http://schemas.openxmlformats.org/drawingml/2006/main">
               <a:ext uri="{FF2B5EF4-FFF2-40B4-BE49-F238E27FC236}">
-                <a16:creationId xmlns:a16="http://schemas.microsoft.com/office/drawing/2014/main" id="{8CDD3922-5D35-4F59-B155-780F08227B12}"/>
+                <a16:creationId xmlns:a16="http://schemas.microsoft.com/office/drawing/2014/main" id="{F940CD92-43A7-4345-91DE-1D61ADC81C68}"/>
               </a:ext>
             </a:extLst>
           </p:cNvPr>
@@ -12387,7 +12387,7 @@
           <p:cNvPr id="12" name="">
             <a:extLst xmlns:a="http://schemas.openxmlformats.org/drawingml/2006/main">
               <a:ext uri="{FF2B5EF4-FFF2-40B4-BE49-F238E27FC236}">
-                <a16:creationId xmlns:a16="http://schemas.microsoft.com/office/drawing/2014/main" id="{47F8FAA1-24E9-44D2-9A5B-0A7DCDEC25C8}"/>
+                <a16:creationId xmlns:a16="http://schemas.microsoft.com/office/drawing/2014/main" id="{43762458-488F-410A-B790-F2D721125540}"/>
               </a:ext>
             </a:extLst>
           </p:cNvPr>
@@ -12420,7 +12420,7 @@
           <p:cNvPr id="13" name="">
             <a:extLst xmlns:a="http://schemas.openxmlformats.org/drawingml/2006/main">
               <a:ext uri="{FF2B5EF4-FFF2-40B4-BE49-F238E27FC236}">
-                <a16:creationId xmlns:a16="http://schemas.microsoft.com/office/drawing/2014/main" id="{5BA5B438-575C-4D85-B35A-FFA0F401F4AF}"/>
+                <a16:creationId xmlns:a16="http://schemas.microsoft.com/office/drawing/2014/main" id="{81F76A0C-AA78-4C6C-BDC2-CCEAFF0C25F6}"/>
               </a:ext>
             </a:extLst>
           </p:cNvPr>
@@ -12453,7 +12453,7 @@
           <p:cNvPr id="14" name="text">
             <a:extLst xmlns:a="http://schemas.openxmlformats.org/drawingml/2006/main">
               <a:ext uri="{FF2B5EF4-FFF2-40B4-BE49-F238E27FC236}">
-                <a16:creationId xmlns:a16="http://schemas.microsoft.com/office/drawing/2014/main" id="{51FDCDF9-F3A3-4A5D-AA72-5DAC7079C94F}"/>
+                <a16:creationId xmlns:a16="http://schemas.microsoft.com/office/drawing/2014/main" id="{DC53C0AA-A4E6-452B-83FF-1207DAB49579}"/>
               </a:ext>
             </a:extLst>
           </p:cNvPr>
@@ -12515,7 +12515,7 @@
           <p:cNvPr id="15" name="text">
             <a:extLst xmlns:a="http://schemas.openxmlformats.org/drawingml/2006/main">
               <a:ext uri="{FF2B5EF4-FFF2-40B4-BE49-F238E27FC236}">
-                <a16:creationId xmlns:a16="http://schemas.microsoft.com/office/drawing/2014/main" id="{CB6D6C68-4D9A-4D04-9044-DA552B5A9B9A}"/>
+                <a16:creationId xmlns:a16="http://schemas.microsoft.com/office/drawing/2014/main" id="{37F82DEE-AFDE-4F73-A32B-9DE720CDE0DE}"/>
               </a:ext>
             </a:extLst>
           </p:cNvPr>
@@ -12577,7 +12577,7 @@
           <p:cNvPr id="16" name="text">
             <a:extLst xmlns:a="http://schemas.openxmlformats.org/drawingml/2006/main">
               <a:ext uri="{FF2B5EF4-FFF2-40B4-BE49-F238E27FC236}">
-                <a16:creationId xmlns:a16="http://schemas.microsoft.com/office/drawing/2014/main" id="{27CE5510-86D3-496D-BA30-FB4F02058BC9}"/>
+                <a16:creationId xmlns:a16="http://schemas.microsoft.com/office/drawing/2014/main" id="{EBA5C979-8FE2-4BD3-8DD3-7C47F254D007}"/>
               </a:ext>
             </a:extLst>
           </p:cNvPr>
@@ -12639,7 +12639,7 @@
           <p:cNvPr id="17" name="">
             <a:extLst xmlns:a="http://schemas.openxmlformats.org/drawingml/2006/main">
               <a:ext uri="{FF2B5EF4-FFF2-40B4-BE49-F238E27FC236}">
-                <a16:creationId xmlns:a16="http://schemas.microsoft.com/office/drawing/2014/main" id="{959BA8AD-6968-4280-9712-F390CCCDAD3F}"/>
+                <a16:creationId xmlns:a16="http://schemas.microsoft.com/office/drawing/2014/main" id="{15B25D50-4FD8-4259-902F-77B5AFDD74D0}"/>
               </a:ext>
             </a:extLst>
           </p:cNvPr>
@@ -12674,7 +12674,7 @@
           <p:cNvPr id="18" name="text">
             <a:extLst xmlns:a="http://schemas.openxmlformats.org/drawingml/2006/main">
               <a:ext uri="{FF2B5EF4-FFF2-40B4-BE49-F238E27FC236}">
-                <a16:creationId xmlns:a16="http://schemas.microsoft.com/office/drawing/2014/main" id="{7F04F509-FDC7-40F3-838D-42D16FEF0B66}"/>
+                <a16:creationId xmlns:a16="http://schemas.microsoft.com/office/drawing/2014/main" id="{6343418B-D5DE-447C-8553-8B1E98B85634}"/>
               </a:ext>
             </a:extLst>
           </p:cNvPr>
@@ -12736,7 +12736,7 @@
           <p:cNvPr id="19" name="text">
             <a:extLst xmlns:a="http://schemas.openxmlformats.org/drawingml/2006/main">
               <a:ext uri="{FF2B5EF4-FFF2-40B4-BE49-F238E27FC236}">
-                <a16:creationId xmlns:a16="http://schemas.microsoft.com/office/drawing/2014/main" id="{C0D92E4B-041A-40FD-996C-A1A88D24A725}"/>
+                <a16:creationId xmlns:a16="http://schemas.microsoft.com/office/drawing/2014/main" id="{0BE4DBCD-AD68-416A-8F83-BBF340DC568E}"/>
               </a:ext>
             </a:extLst>
           </p:cNvPr>
@@ -12798,7 +12798,7 @@
           <p:cNvPr id="20" name="slide-number">
             <a:extLst xmlns:a="http://schemas.openxmlformats.org/drawingml/2006/main">
               <a:ext uri="{FF2B5EF4-FFF2-40B4-BE49-F238E27FC236}">
-                <a16:creationId xmlns:a16="http://schemas.microsoft.com/office/drawing/2014/main" id="{4EE8BC68-B4F0-4B70-85CC-D384A1C9CAA7}"/>
+                <a16:creationId xmlns:a16="http://schemas.microsoft.com/office/drawing/2014/main" id="{E9EF75C4-82DF-4B59-A179-29F29BDDED63}"/>
               </a:ext>
             </a:extLst>
           </p:cNvPr>
@@ -12858,7 +12858,7 @@
     </p:spTree>
     <p:extLst>
       <p:ext uri="{BB962C8B-B14F-4D97-AF65-F5344CB8AC3E}">
-        <p14:creationId xmlns:p14="http://schemas.microsoft.com/office/powerpoint/2010/main" val="1173324499"/>
+        <p14:creationId xmlns:p14="http://schemas.microsoft.com/office/powerpoint/2010/main" val="1382693922"/>
       </p:ext>
     </p:extLst>
   </p:cSld>

</xml_diff>